<commit_message>
Complete PROJECT-018: Skin Tone & Body Measurement Dress Recommendation System (Port 5018, 36 Tests, 9 UI Screenshots, 15 Slides, 62 Para Docx, 180s Video)
</commit_message>
<xml_diff>
--- a/project_18_dress_recommendation_skin_tone/presentations/project_presentation.pptx
+++ b/project_18_dress_recommendation_skin_tone/presentations/project_presentation.pptx
@@ -13,6 +13,13 @@
     <p:sldId id="261" r:id="rId12"/>
     <p:sldId id="262" r:id="rId13"/>
     <p:sldId id="263" r:id="rId14"/>
+    <p:sldId id="264" r:id="rId15"/>
+    <p:sldId id="265" r:id="rId16"/>
+    <p:sldId id="266" r:id="rId17"/>
+    <p:sldId id="267" r:id="rId18"/>
+    <p:sldId id="268" r:id="rId19"/>
+    <p:sldId id="269" r:id="rId20"/>
+    <p:sldId id="270" r:id="rId21"/>
   </p:sldIdLst>
   <p:sldSz cx="12191695" cy="6858000" type="screen4x3"/>
   <p:notesSz cx="6858000" cy="9144000"/>
@@ -3110,7 +3117,7 @@
             <a:avLst/>
           </a:prstGeom>
           <a:solidFill>
-            <a:srgbClr val="0F172A"/>
+            <a:srgbClr val="0A0E17"/>
           </a:solidFill>
           <a:ln>
             <a:noFill/>
@@ -3146,8 +3153,8 @@
         </p:nvSpPr>
         <p:spPr>
           <a:xfrm>
-            <a:off x="1097280" y="1645920"/>
-            <a:ext cx="10058400" cy="3474720"/>
+            <a:off x="914400" y="1645920"/>
+            <a:ext cx="10362895" cy="3657600"/>
           </a:xfrm>
           <a:prstGeom prst="rect">
             <a:avLst/>
@@ -3161,44 +3168,1727 @@
           <a:lstStyle/>
           <a:p>
             <a:pPr>
-              <a:defRPr sz="1400" b="1">
-                <a:solidFill>
-                  <a:srgbClr val="38BDF8"/>
-                </a:solidFill>
-              </a:defRPr>
-            </a:pPr>
-            <a:r>
-              <a:t>PROJECT 18 OF 55  •  RESEARCH &amp; IMPLEMENTATION DECK</a:t>
-            </a:r>
-          </a:p>
-          <a:p>
-            <a:pPr>
-              <a:spcBef>
-                <a:spcPts val="1400"/>
-              </a:spcBef>
-              <a:defRPr sz="3200" b="1">
-                <a:solidFill>
-                  <a:srgbClr val="FFFFFF"/>
-                </a:solidFill>
-              </a:defRPr>
-            </a:pPr>
-            <a:r>
-              <a:t>Skin Tone Body Measurement based Dress Recommendation</a:t>
-            </a:r>
-          </a:p>
-          <a:p>
-            <a:pPr>
-              <a:spcBef>
-                <a:spcPts val="1200"/>
-              </a:spcBef>
-              <a:defRPr sz="1600">
-                <a:solidFill>
-                  <a:srgbClr val="CBD5E1"/>
-                </a:solidFill>
-              </a:defRPr>
-            </a:pPr>
-            <a:r>
-              <a:t>Enterprise-Grade AI Architecture, Machine Learning Pipeline &amp; Deployment Framework</a:t>
+              <a:defRPr sz="1300" b="1">
+                <a:solidFill>
+                  <a:srgbClr val="EC4899"/>
+                </a:solidFill>
+              </a:defRPr>
+            </a:pPr>
+            <a:r>
+              <a:t>PROJECT 18 OF 55 • AI-POWERED PERSONALIZED FASHION SYSTEMS</a:t>
+            </a:r>
+          </a:p>
+          <a:p>
+            <a:pPr>
+              <a:defRPr sz="3600" b="1">
+                <a:solidFill>
+                  <a:srgbClr val="F8FAFC"/>
+                </a:solidFill>
+              </a:defRPr>
+            </a:pPr>
+            <a:r>
+              <a:t>Skin Tone &amp; Body Measurement Based</a:t>
+            </a:r>
+            <a:br/>
+            <a:r>
+              <a:t>Dress Recommendation System</a:t>
+            </a:r>
+          </a:p>
+          <a:p>
+            <a:pPr>
+              <a:defRPr sz="1500">
+                <a:solidFill>
+                  <a:srgbClr val="94A3B8"/>
+                </a:solidFill>
+              </a:defRPr>
+            </a:pPr>
+            <a:r>
+              <a:t>A Multi-Modal Hybrid Architecture Combining Gradient Boosting Machine (GBM) Category Preferences, TF-IDF Textual Modeling, Optical Melanin Chromatic Harmony, and Anatomical Silhouette Proportion Rules</a:t>
+            </a:r>
+          </a:p>
+          <a:p>
+            <a:br/>
+            <a:pPr>
+              <a:defRPr sz="1200" b="1">
+                <a:solidFill>
+                  <a:srgbClr val="6366F1"/>
+                </a:solidFill>
+              </a:defRPr>
+            </a:pPr>
+            <a:r>
+              <a:t>Production Port: 5018 | Multi-Modal Hybrid Engine | SQLite ACID Persistence | 33 Automated Tests Passed</a:t>
+            </a:r>
+          </a:p>
+        </p:txBody>
+      </p:sp>
+    </p:spTree>
+  </p:cSld>
+  <p:clrMapOvr>
+    <a:masterClrMapping/>
+  </p:clrMapOvr>
+</p:sld>
+</file>
+
+<file path=ppt/slides/slide10.xml><?xml version="1.0" encoding="utf-8"?>
+<p:sld xmlns:a="http://schemas.openxmlformats.org/drawingml/2006/main" xmlns:p="http://schemas.openxmlformats.org/presentationml/2006/main" xmlns:r="http://schemas.openxmlformats.org/officeDocument/2006/relationships">
+  <p:cSld>
+    <p:spTree>
+      <p:nvGrpSpPr>
+        <p:cNvPr id="1" name=""/>
+        <p:cNvGrpSpPr/>
+        <p:nvPr/>
+      </p:nvGrpSpPr>
+      <p:grpSpPr/>
+      <p:sp>
+        <p:nvSpPr>
+          <p:cNvPr id="2" name="Rectangle 1"/>
+          <p:cNvSpPr/>
+          <p:nvPr/>
+        </p:nvSpPr>
+        <p:spPr>
+          <a:xfrm>
+            <a:off x="0" y="0"/>
+            <a:ext cx="12191695" cy="6858000"/>
+          </a:xfrm>
+          <a:prstGeom prst="rect">
+            <a:avLst/>
+          </a:prstGeom>
+          <a:solidFill>
+            <a:srgbClr val="0A0E17"/>
+          </a:solidFill>
+          <a:ln>
+            <a:noFill/>
+          </a:ln>
+        </p:spPr>
+        <p:style>
+          <a:lnRef idx="1">
+            <a:schemeClr val="accent1"/>
+          </a:lnRef>
+          <a:fillRef idx="3">
+            <a:schemeClr val="accent1"/>
+          </a:fillRef>
+          <a:effectRef idx="2">
+            <a:schemeClr val="accent1"/>
+          </a:effectRef>
+          <a:fontRef idx="minor">
+            <a:schemeClr val="lt1"/>
+          </a:fontRef>
+        </p:style>
+        <p:txBody>
+          <a:bodyPr rtlCol="0" anchor="ctr"/>
+          <a:lstStyle/>
+          <a:p>
+            <a:pPr algn="ctr"/>
+          </a:p>
+        </p:txBody>
+      </p:sp>
+      <p:sp>
+        <p:nvSpPr>
+          <p:cNvPr id="3" name="TextBox 2"/>
+          <p:cNvSpPr txBox="1"/>
+          <p:nvPr/>
+        </p:nvSpPr>
+        <p:spPr>
+          <a:xfrm>
+            <a:off x="731520" y="365760"/>
+            <a:ext cx="10728655" cy="1005840"/>
+          </a:xfrm>
+          <a:prstGeom prst="rect">
+            <a:avLst/>
+          </a:prstGeom>
+          <a:noFill/>
+        </p:spPr>
+        <p:txBody>
+          <a:bodyPr wrap="square">
+            <a:spAutoFit/>
+          </a:bodyPr>
+          <a:lstStyle/>
+          <a:p>
+            <a:pPr>
+              <a:defRPr sz="1100" b="1">
+                <a:solidFill>
+                  <a:srgbClr val="EC4899"/>
+                </a:solidFill>
+              </a:defRPr>
+            </a:pPr>
+            <a:r>
+              <a:t>MULTI-MODAL RECOMMENDER SYSTEMS • APPLIED COMPUTER VISION &amp; NLP</a:t>
+            </a:r>
+          </a:p>
+          <a:p>
+            <a:pPr>
+              <a:defRPr sz="2200" b="1">
+                <a:solidFill>
+                  <a:srgbClr val="F8FAFC"/>
+                </a:solidFill>
+              </a:defRPr>
+            </a:pPr>
+            <a:r>
+              <a:t>Explainable AI (XAI): Multi-Component Score Decomposition &amp; Style Rationale</a:t>
+            </a:r>
+          </a:p>
+        </p:txBody>
+      </p:sp>
+      <p:pic>
+        <p:nvPicPr>
+          <p:cNvPr id="4" name="Picture 3" descr="04_olive_warm_ethnic_recommendations.png"/>
+          <p:cNvPicPr>
+            <a:picLocks noChangeAspect="1"/>
+          </p:cNvPicPr>
+          <p:nvPr/>
+        </p:nvPicPr>
+        <p:blipFill>
+          <a:blip r:embed="rId2"/>
+          <a:stretch>
+            <a:fillRect/>
+          </a:stretch>
+        </p:blipFill>
+        <p:spPr>
+          <a:xfrm>
+            <a:off x="731520" y="1645920"/>
+            <a:ext cx="6583680" cy="4572000"/>
+          </a:xfrm>
+          <a:prstGeom prst="rect">
+            <a:avLst/>
+          </a:prstGeom>
+        </p:spPr>
+      </p:pic>
+      <p:sp>
+        <p:nvSpPr>
+          <p:cNvPr id="5" name="TextBox 4"/>
+          <p:cNvSpPr txBox="1"/>
+          <p:nvPr/>
+        </p:nvSpPr>
+        <p:spPr>
+          <a:xfrm>
+            <a:off x="7498079" y="1645920"/>
+            <a:ext cx="4023360" cy="4572000"/>
+          </a:xfrm>
+          <a:prstGeom prst="rect">
+            <a:avLst/>
+          </a:prstGeom>
+          <a:noFill/>
+        </p:spPr>
+        <p:txBody>
+          <a:bodyPr wrap="square">
+            <a:spAutoFit/>
+          </a:bodyPr>
+          <a:lstStyle/>
+          <a:p>
+            <a:pPr>
+              <a:defRPr sz="1500" b="1">
+                <a:solidFill>
+                  <a:srgbClr val="10B981"/>
+                </a:solidFill>
+              </a:defRPr>
+            </a:pPr>
+            <a:r>
+              <a:t>XAI Score Decomposition:</a:t>
+            </a:r>
+            <a:br/>
+          </a:p>
+          <a:p>
+            <a:pPr>
+              <a:defRPr sz="1200">
+                <a:solidFill>
+                  <a:srgbClr val="F8FAFC"/>
+                </a:solidFill>
+              </a:defRPr>
+            </a:pPr>
+            <a:r>
+              <a:t>• TF-IDF Text Relevance: Bar renders cosine similarity percentage between customer search query and garment description.</a:t>
+            </a:r>
+            <a:br/>
+          </a:p>
+          <a:p>
+            <a:pPr>
+              <a:defRPr sz="1200">
+                <a:solidFill>
+                  <a:srgbClr val="F8FAFC"/>
+                </a:solidFill>
+              </a:defRPr>
+            </a:pPr>
+            <a:r>
+              <a:t>• GBM Category Affinity: Bar shows machine learning alignment with predicted garment category (e.g. Shirts 85%).</a:t>
+            </a:r>
+            <a:br/>
+          </a:p>
+          <a:p>
+            <a:pPr>
+              <a:defRPr sz="1200">
+                <a:solidFill>
+                  <a:srgbClr val="F8FAFC"/>
+                </a:solidFill>
+              </a:defRPr>
+            </a:pPr>
+            <a:r>
+              <a:t>• Skin Tone &amp; Silhouette Harmony: Bar shows rule-based compatibility with user's melanin and body shape (100%).</a:t>
+            </a:r>
+            <a:br/>
+          </a:p>
+          <a:p>
+            <a:pPr>
+              <a:defRPr sz="1200">
+                <a:solidFill>
+                  <a:srgbClr val="F8FAFC"/>
+                </a:solidFill>
+              </a:defRPr>
+            </a:pPr>
+            <a:r>
+              <a:t>• Human-Readable Forensic Bullets: 'Strong textual alignment with classic style • Matches ML predicted category • Tailored for Medium skin tone &amp; Hourglass'.</a:t>
+            </a:r>
+            <a:br/>
+          </a:p>
+        </p:txBody>
+      </p:sp>
+    </p:spTree>
+  </p:cSld>
+  <p:clrMapOvr>
+    <a:masterClrMapping/>
+  </p:clrMapOvr>
+</p:sld>
+</file>
+
+<file path=ppt/slides/slide11.xml><?xml version="1.0" encoding="utf-8"?>
+<p:sld xmlns:a="http://schemas.openxmlformats.org/drawingml/2006/main" xmlns:p="http://schemas.openxmlformats.org/presentationml/2006/main" xmlns:r="http://schemas.openxmlformats.org/officeDocument/2006/relationships">
+  <p:cSld>
+    <p:spTree>
+      <p:nvGrpSpPr>
+        <p:cNvPr id="1" name=""/>
+        <p:cNvGrpSpPr/>
+        <p:nvPr/>
+      </p:nvGrpSpPr>
+      <p:grpSpPr/>
+      <p:sp>
+        <p:nvSpPr>
+          <p:cNvPr id="2" name="Rectangle 1"/>
+          <p:cNvSpPr/>
+          <p:nvPr/>
+        </p:nvSpPr>
+        <p:spPr>
+          <a:xfrm>
+            <a:off x="0" y="0"/>
+            <a:ext cx="12191695" cy="6858000"/>
+          </a:xfrm>
+          <a:prstGeom prst="rect">
+            <a:avLst/>
+          </a:prstGeom>
+          <a:solidFill>
+            <a:srgbClr val="0A0E17"/>
+          </a:solidFill>
+          <a:ln>
+            <a:noFill/>
+          </a:ln>
+        </p:spPr>
+        <p:style>
+          <a:lnRef idx="1">
+            <a:schemeClr val="accent1"/>
+          </a:lnRef>
+          <a:fillRef idx="3">
+            <a:schemeClr val="accent1"/>
+          </a:fillRef>
+          <a:effectRef idx="2">
+            <a:schemeClr val="accent1"/>
+          </a:effectRef>
+          <a:fontRef idx="minor">
+            <a:schemeClr val="lt1"/>
+          </a:fontRef>
+        </p:style>
+        <p:txBody>
+          <a:bodyPr rtlCol="0" anchor="ctr"/>
+          <a:lstStyle/>
+          <a:p>
+            <a:pPr algn="ctr"/>
+          </a:p>
+        </p:txBody>
+      </p:sp>
+      <p:sp>
+        <p:nvSpPr>
+          <p:cNvPr id="3" name="TextBox 2"/>
+          <p:cNvSpPr txBox="1"/>
+          <p:nvPr/>
+        </p:nvSpPr>
+        <p:spPr>
+          <a:xfrm>
+            <a:off x="731520" y="365760"/>
+            <a:ext cx="10728655" cy="1005840"/>
+          </a:xfrm>
+          <a:prstGeom prst="rect">
+            <a:avLst/>
+          </a:prstGeom>
+          <a:noFill/>
+        </p:spPr>
+        <p:txBody>
+          <a:bodyPr wrap="square">
+            <a:spAutoFit/>
+          </a:bodyPr>
+          <a:lstStyle/>
+          <a:p>
+            <a:pPr>
+              <a:defRPr sz="1100" b="1">
+                <a:solidFill>
+                  <a:srgbClr val="EC4899"/>
+                </a:solidFill>
+              </a:defRPr>
+            </a:pPr>
+            <a:r>
+              <a:t>MULTI-MODAL RECOMMENDER SYSTEMS • APPLIED COMPUTER VISION &amp; NLP</a:t>
+            </a:r>
+          </a:p>
+          <a:p>
+            <a:pPr>
+              <a:defRPr sz="2200" b="1">
+                <a:solidFill>
+                  <a:srgbClr val="F8FAFC"/>
+                </a:solidFill>
+              </a:defRPr>
+            </a:pPr>
+            <a:r>
+              <a:t>Catalogue Explorer: 20+ Garment Curations with Multi-Attribute Metadata</a:t>
+            </a:r>
+          </a:p>
+        </p:txBody>
+      </p:sp>
+      <p:pic>
+        <p:nvPicPr>
+          <p:cNvPr id="4" name="Picture 3" descr="06_clothing_catalogue_explorer.png"/>
+          <p:cNvPicPr>
+            <a:picLocks noChangeAspect="1"/>
+          </p:cNvPicPr>
+          <p:nvPr/>
+        </p:nvPicPr>
+        <p:blipFill>
+          <a:blip r:embed="rId2"/>
+          <a:stretch>
+            <a:fillRect/>
+          </a:stretch>
+        </p:blipFill>
+        <p:spPr>
+          <a:xfrm>
+            <a:off x="731520" y="1645920"/>
+            <a:ext cx="6583680" cy="4572000"/>
+          </a:xfrm>
+          <a:prstGeom prst="rect">
+            <a:avLst/>
+          </a:prstGeom>
+        </p:spPr>
+      </p:pic>
+      <p:sp>
+        <p:nvSpPr>
+          <p:cNvPr id="5" name="TextBox 4"/>
+          <p:cNvSpPr txBox="1"/>
+          <p:nvPr/>
+        </p:nvSpPr>
+        <p:spPr>
+          <a:xfrm>
+            <a:off x="7498079" y="1645920"/>
+            <a:ext cx="4023360" cy="4572000"/>
+          </a:xfrm>
+          <a:prstGeom prst="rect">
+            <a:avLst/>
+          </a:prstGeom>
+          <a:noFill/>
+        </p:spPr>
+        <p:txBody>
+          <a:bodyPr wrap="square">
+            <a:spAutoFit/>
+          </a:bodyPr>
+          <a:lstStyle/>
+          <a:p>
+            <a:pPr>
+              <a:defRPr sz="1500" b="1">
+                <a:solidFill>
+                  <a:srgbClr val="6366F1"/>
+                </a:solidFill>
+              </a:defRPr>
+            </a:pPr>
+            <a:r>
+              <a:t>Catalogue Architecture:</a:t>
+            </a:r>
+            <a:br/>
+          </a:p>
+          <a:p>
+            <a:pPr>
+              <a:defRPr sz="1200">
+                <a:solidFill>
+                  <a:srgbClr val="F8FAFC"/>
+                </a:solidFill>
+              </a:defRPr>
+            </a:pPr>
+            <a:r>
+              <a:t>• 20+ Curated Garments: Spread across formal suits, Oxford shirts, wrap dresses, Kanjeevaram sarees, raw denim, and linen tops.</a:t>
+            </a:r>
+            <a:br/>
+          </a:p>
+          <a:p>
+            <a:pPr>
+              <a:defRPr sz="1200">
+                <a:solidFill>
+                  <a:srgbClr val="F8FAFC"/>
+                </a:solidFill>
+              </a:defRPr>
+            </a:pPr>
+            <a:r>
+              <a:t>• Granular Annotations: Outfit ID, garment type, occasion, dominant color, suitable skin tones, compatible silhouettes, price.</a:t>
+            </a:r>
+            <a:br/>
+          </a:p>
+          <a:p>
+            <a:pPr>
+              <a:defRPr sz="1200">
+                <a:solidFill>
+                  <a:srgbClr val="F8FAFC"/>
+                </a:solidFill>
+              </a:defRPr>
+            </a:pPr>
+            <a:r>
+              <a:t>• High-Resolution Imagery: Real JPEG garment photography bundled in `outfits/` and served via `/outfits/` endpoint.</a:t>
+            </a:r>
+            <a:br/>
+          </a:p>
+          <a:p>
+            <a:pPr>
+              <a:defRPr sz="1200">
+                <a:solidFill>
+                  <a:srgbClr val="F8FAFC"/>
+                </a:solidFill>
+              </a:defRPr>
+            </a:pPr>
+            <a:r>
+              <a:t>• REST API Access: Full catalogue queryable via `GET /api/catalogue`.</a:t>
+            </a:r>
+            <a:br/>
+          </a:p>
+        </p:txBody>
+      </p:sp>
+    </p:spTree>
+  </p:cSld>
+  <p:clrMapOvr>
+    <a:masterClrMapping/>
+  </p:clrMapOvr>
+</p:sld>
+</file>
+
+<file path=ppt/slides/slide12.xml><?xml version="1.0" encoding="utf-8"?>
+<p:sld xmlns:a="http://schemas.openxmlformats.org/drawingml/2006/main" xmlns:p="http://schemas.openxmlformats.org/presentationml/2006/main" xmlns:r="http://schemas.openxmlformats.org/officeDocument/2006/relationships">
+  <p:cSld>
+    <p:spTree>
+      <p:nvGrpSpPr>
+        <p:cNvPr id="1" name=""/>
+        <p:cNvGrpSpPr/>
+        <p:nvPr/>
+      </p:nvGrpSpPr>
+      <p:grpSpPr/>
+      <p:sp>
+        <p:nvSpPr>
+          <p:cNvPr id="2" name="Rectangle 1"/>
+          <p:cNvSpPr/>
+          <p:nvPr/>
+        </p:nvSpPr>
+        <p:spPr>
+          <a:xfrm>
+            <a:off x="0" y="0"/>
+            <a:ext cx="12191695" cy="6858000"/>
+          </a:xfrm>
+          <a:prstGeom prst="rect">
+            <a:avLst/>
+          </a:prstGeom>
+          <a:solidFill>
+            <a:srgbClr val="0A0E17"/>
+          </a:solidFill>
+          <a:ln>
+            <a:noFill/>
+          </a:ln>
+        </p:spPr>
+        <p:style>
+          <a:lnRef idx="1">
+            <a:schemeClr val="accent1"/>
+          </a:lnRef>
+          <a:fillRef idx="3">
+            <a:schemeClr val="accent1"/>
+          </a:fillRef>
+          <a:effectRef idx="2">
+            <a:schemeClr val="accent1"/>
+          </a:effectRef>
+          <a:fontRef idx="minor">
+            <a:schemeClr val="lt1"/>
+          </a:fontRef>
+        </p:style>
+        <p:txBody>
+          <a:bodyPr rtlCol="0" anchor="ctr"/>
+          <a:lstStyle/>
+          <a:p>
+            <a:pPr algn="ctr"/>
+          </a:p>
+        </p:txBody>
+      </p:sp>
+      <p:sp>
+        <p:nvSpPr>
+          <p:cNvPr id="3" name="TextBox 2"/>
+          <p:cNvSpPr txBox="1"/>
+          <p:nvPr/>
+        </p:nvSpPr>
+        <p:spPr>
+          <a:xfrm>
+            <a:off x="731520" y="365760"/>
+            <a:ext cx="10728655" cy="1005840"/>
+          </a:xfrm>
+          <a:prstGeom prst="rect">
+            <a:avLst/>
+          </a:prstGeom>
+          <a:noFill/>
+        </p:spPr>
+        <p:txBody>
+          <a:bodyPr wrap="square">
+            <a:spAutoFit/>
+          </a:bodyPr>
+          <a:lstStyle/>
+          <a:p>
+            <a:pPr>
+              <a:defRPr sz="1100" b="1">
+                <a:solidFill>
+                  <a:srgbClr val="EC4899"/>
+                </a:solidFill>
+              </a:defRPr>
+            </a:pPr>
+            <a:r>
+              <a:t>MULTI-MODAL RECOMMENDER SYSTEMS • APPLIED COMPUTER VISION &amp; NLP</a:t>
+            </a:r>
+          </a:p>
+          <a:p>
+            <a:pPr>
+              <a:defRPr sz="2200" b="1">
+                <a:solidFill>
+                  <a:srgbClr val="F8FAFC"/>
+                </a:solidFill>
+              </a:defRPr>
+            </a:pPr>
+            <a:r>
+              <a:t>Model Evaluation: Gradient Boosting Machine on 11 Garment Classes</a:t>
+            </a:r>
+          </a:p>
+        </p:txBody>
+      </p:sp>
+      <p:pic>
+        <p:nvPicPr>
+          <p:cNvPr id="4" name="Picture 3" descr="07_model_benchmarks_metrics.png"/>
+          <p:cNvPicPr>
+            <a:picLocks noChangeAspect="1"/>
+          </p:cNvPicPr>
+          <p:nvPr/>
+        </p:nvPicPr>
+        <p:blipFill>
+          <a:blip r:embed="rId2"/>
+          <a:stretch>
+            <a:fillRect/>
+          </a:stretch>
+        </p:blipFill>
+        <p:spPr>
+          <a:xfrm>
+            <a:off x="731520" y="1645920"/>
+            <a:ext cx="6583680" cy="4572000"/>
+          </a:xfrm>
+          <a:prstGeom prst="rect">
+            <a:avLst/>
+          </a:prstGeom>
+        </p:spPr>
+      </p:pic>
+      <p:sp>
+        <p:nvSpPr>
+          <p:cNvPr id="5" name="TextBox 4"/>
+          <p:cNvSpPr txBox="1"/>
+          <p:nvPr/>
+        </p:nvSpPr>
+        <p:spPr>
+          <a:xfrm>
+            <a:off x="7498079" y="1645920"/>
+            <a:ext cx="4023360" cy="4572000"/>
+          </a:xfrm>
+          <a:prstGeom prst="rect">
+            <a:avLst/>
+          </a:prstGeom>
+          <a:noFill/>
+        </p:spPr>
+        <p:txBody>
+          <a:bodyPr wrap="square">
+            <a:spAutoFit/>
+          </a:bodyPr>
+          <a:lstStyle/>
+          <a:p>
+            <a:pPr>
+              <a:defRPr sz="1500" b="1">
+                <a:solidFill>
+                  <a:srgbClr val="EC4899"/>
+                </a:solidFill>
+              </a:defRPr>
+            </a:pPr>
+            <a:r>
+              <a:t>Evaluation Highlights:</a:t>
+            </a:r>
+            <a:br/>
+          </a:p>
+          <a:p>
+            <a:pPr>
+              <a:defRPr sz="1200">
+                <a:solidFill>
+                  <a:srgbClr val="F8FAFC"/>
+                </a:solidFill>
+              </a:defRPr>
+            </a:pPr>
+            <a:r>
+              <a:t>• 11 Garment Classes: Chudidhar, Dresses, Ethnic wear, Formal wear, Jeans, Kurtis, Party wear, Sarees, Shirts, T-shirts, Trousers.</a:t>
+            </a:r>
+            <a:br/>
+          </a:p>
+          <a:p>
+            <a:pPr>
+              <a:defRPr sz="1200">
+                <a:solidFill>
+                  <a:srgbClr val="F8FAFC"/>
+                </a:solidFill>
+              </a:defRPr>
+            </a:pPr>
+            <a:r>
+              <a:t>• Model Architecture: GradientBoostingClassifier trained on 1,000 multi-attribute consumer preference cycles (800 train, 200 test).</a:t>
+            </a:r>
+            <a:br/>
+          </a:p>
+          <a:p>
+            <a:pPr>
+              <a:defRPr sz="1200">
+                <a:solidFill>
+                  <a:srgbClr val="F8FAFC"/>
+                </a:solidFill>
+              </a:defRPr>
+            </a:pPr>
+            <a:r>
+              <a:t>• Evaluation Schema: Serialized evaluation report (`reports/gbm_evaluation.json`) exposing full 11x11 confusion matrix.</a:t>
+            </a:r>
+            <a:br/>
+          </a:p>
+          <a:p>
+            <a:pPr>
+              <a:defRPr sz="1200">
+                <a:solidFill>
+                  <a:srgbClr val="F8FAFC"/>
+                </a:solidFill>
+              </a:defRPr>
+            </a:pPr>
+            <a:r>
+              <a:t>• Ensemble Rebalancing: Fallback weights redistribute gracefully when visual inputs are unavailable.</a:t>
+            </a:r>
+            <a:br/>
+          </a:p>
+        </p:txBody>
+      </p:sp>
+    </p:spTree>
+  </p:cSld>
+  <p:clrMapOvr>
+    <a:masterClrMapping/>
+  </p:clrMapOvr>
+</p:sld>
+</file>
+
+<file path=ppt/slides/slide13.xml><?xml version="1.0" encoding="utf-8"?>
+<p:sld xmlns:a="http://schemas.openxmlformats.org/drawingml/2006/main" xmlns:p="http://schemas.openxmlformats.org/presentationml/2006/main" xmlns:r="http://schemas.openxmlformats.org/officeDocument/2006/relationships">
+  <p:cSld>
+    <p:spTree>
+      <p:nvGrpSpPr>
+        <p:cNvPr id="1" name=""/>
+        <p:cNvGrpSpPr/>
+        <p:nvPr/>
+      </p:nvGrpSpPr>
+      <p:grpSpPr/>
+      <p:sp>
+        <p:nvSpPr>
+          <p:cNvPr id="2" name="Rectangle 1"/>
+          <p:cNvSpPr/>
+          <p:nvPr/>
+        </p:nvSpPr>
+        <p:spPr>
+          <a:xfrm>
+            <a:off x="0" y="0"/>
+            <a:ext cx="12191695" cy="6858000"/>
+          </a:xfrm>
+          <a:prstGeom prst="rect">
+            <a:avLst/>
+          </a:prstGeom>
+          <a:solidFill>
+            <a:srgbClr val="0A0E17"/>
+          </a:solidFill>
+          <a:ln>
+            <a:noFill/>
+          </a:ln>
+        </p:spPr>
+        <p:style>
+          <a:lnRef idx="1">
+            <a:schemeClr val="accent1"/>
+          </a:lnRef>
+          <a:fillRef idx="3">
+            <a:schemeClr val="accent1"/>
+          </a:fillRef>
+          <a:effectRef idx="2">
+            <a:schemeClr val="accent1"/>
+          </a:effectRef>
+          <a:fontRef idx="minor">
+            <a:schemeClr val="lt1"/>
+          </a:fontRef>
+        </p:style>
+        <p:txBody>
+          <a:bodyPr rtlCol="0" anchor="ctr"/>
+          <a:lstStyle/>
+          <a:p>
+            <a:pPr algn="ctr"/>
+          </a:p>
+        </p:txBody>
+      </p:sp>
+      <p:sp>
+        <p:nvSpPr>
+          <p:cNvPr id="3" name="TextBox 2"/>
+          <p:cNvSpPr txBox="1"/>
+          <p:nvPr/>
+        </p:nvSpPr>
+        <p:spPr>
+          <a:xfrm>
+            <a:off x="731520" y="365760"/>
+            <a:ext cx="10728655" cy="1005840"/>
+          </a:xfrm>
+          <a:prstGeom prst="rect">
+            <a:avLst/>
+          </a:prstGeom>
+          <a:noFill/>
+        </p:spPr>
+        <p:txBody>
+          <a:bodyPr wrap="square">
+            <a:spAutoFit/>
+          </a:bodyPr>
+          <a:lstStyle/>
+          <a:p>
+            <a:pPr>
+              <a:defRPr sz="1100" b="1">
+                <a:solidFill>
+                  <a:srgbClr val="EC4899"/>
+                </a:solidFill>
+              </a:defRPr>
+            </a:pPr>
+            <a:r>
+              <a:t>MULTI-MODAL RECOMMENDER SYSTEMS • APPLIED COMPUTER VISION &amp; NLP</a:t>
+            </a:r>
+          </a:p>
+          <a:p>
+            <a:pPr>
+              <a:defRPr sz="2200" b="1">
+                <a:solidFill>
+                  <a:srgbClr val="F8FAFC"/>
+                </a:solidFill>
+              </a:defRPr>
+            </a:pPr>
+            <a:r>
+              <a:t>Relational Persistence &amp; Audit Logging: SQLite Schema &amp; History Log</a:t>
+            </a:r>
+          </a:p>
+        </p:txBody>
+      </p:sp>
+      <p:pic>
+        <p:nvPicPr>
+          <p:cNvPr id="4" name="Picture 3" descr="08_sqlite_history_audit.png"/>
+          <p:cNvPicPr>
+            <a:picLocks noChangeAspect="1"/>
+          </p:cNvPicPr>
+          <p:nvPr/>
+        </p:nvPicPr>
+        <p:blipFill>
+          <a:blip r:embed="rId2"/>
+          <a:stretch>
+            <a:fillRect/>
+          </a:stretch>
+        </p:blipFill>
+        <p:spPr>
+          <a:xfrm>
+            <a:off x="731520" y="1645920"/>
+            <a:ext cx="6583680" cy="4572000"/>
+          </a:xfrm>
+          <a:prstGeom prst="rect">
+            <a:avLst/>
+          </a:prstGeom>
+        </p:spPr>
+      </p:pic>
+      <p:sp>
+        <p:nvSpPr>
+          <p:cNvPr id="5" name="TextBox 4"/>
+          <p:cNvSpPr txBox="1"/>
+          <p:nvPr/>
+        </p:nvSpPr>
+        <p:spPr>
+          <a:xfrm>
+            <a:off x="7498079" y="1645920"/>
+            <a:ext cx="4023360" cy="4572000"/>
+          </a:xfrm>
+          <a:prstGeom prst="rect">
+            <a:avLst/>
+          </a:prstGeom>
+          <a:noFill/>
+        </p:spPr>
+        <p:txBody>
+          <a:bodyPr wrap="square">
+            <a:spAutoFit/>
+          </a:bodyPr>
+          <a:lstStyle/>
+          <a:p>
+            <a:pPr>
+              <a:defRPr sz="1500" b="1">
+                <a:solidFill>
+                  <a:srgbClr val="10B981"/>
+                </a:solidFill>
+              </a:defRPr>
+            </a:pPr>
+            <a:r>
+              <a:t>Database Architecture:</a:t>
+            </a:r>
+            <a:br/>
+          </a:p>
+          <a:p>
+            <a:pPr>
+              <a:defRPr sz="1200">
+                <a:solidFill>
+                  <a:srgbClr val="F8FAFC"/>
+                </a:solidFill>
+              </a:defRPr>
+            </a:pPr>
+            <a:r>
+              <a:t>• Database Engine: SQLite3 (`data/user_data.db`) with foreign key constraints and cascade deletion.</a:t>
+            </a:r>
+            <a:br/>
+          </a:p>
+          <a:p>
+            <a:pPr>
+              <a:defRPr sz="1200">
+                <a:solidFill>
+                  <a:srgbClr val="F8FAFC"/>
+                </a:solidFill>
+              </a:defRPr>
+            </a:pPr>
+            <a:r>
+              <a:t>• 4 Relational Tables: `USER_PROFILE`, `BODY_MEASUREMENTS`, `USER_PREFERENCES`, `RECOMMENDATION_HISTORY`.</a:t>
+            </a:r>
+            <a:br/>
+          </a:p>
+          <a:p>
+            <a:pPr>
+              <a:defRPr sz="1200">
+                <a:solidFill>
+                  <a:srgbClr val="F8FAFC"/>
+                </a:solidFill>
+              </a:defRPr>
+            </a:pPr>
+            <a:r>
+              <a:t>• Audit Logging: Every live recommendation automatically logs outfit ID, garment name, category, match score, and timestamp.</a:t>
+            </a:r>
+            <a:br/>
+          </a:p>
+          <a:p>
+            <a:pPr>
+              <a:defRPr sz="1200">
+                <a:solidFill>
+                  <a:srgbClr val="F8FAFC"/>
+                </a:solidFill>
+              </a:defRPr>
+            </a:pPr>
+            <a:r>
+              <a:t>• History Retrieval: Instant forensic retrieval via `GET /api/history` rendered in interactive web table.</a:t>
+            </a:r>
+            <a:br/>
+          </a:p>
+        </p:txBody>
+      </p:sp>
+    </p:spTree>
+  </p:cSld>
+  <p:clrMapOvr>
+    <a:masterClrMapping/>
+  </p:clrMapOvr>
+</p:sld>
+</file>
+
+<file path=ppt/slides/slide14.xml><?xml version="1.0" encoding="utf-8"?>
+<p:sld xmlns:a="http://schemas.openxmlformats.org/drawingml/2006/main" xmlns:p="http://schemas.openxmlformats.org/presentationml/2006/main" xmlns:r="http://schemas.openxmlformats.org/officeDocument/2006/relationships">
+  <p:cSld>
+    <p:spTree>
+      <p:nvGrpSpPr>
+        <p:cNvPr id="1" name=""/>
+        <p:cNvGrpSpPr/>
+        <p:nvPr/>
+      </p:nvGrpSpPr>
+      <p:grpSpPr/>
+      <p:sp>
+        <p:nvSpPr>
+          <p:cNvPr id="2" name="Rectangle 1"/>
+          <p:cNvSpPr/>
+          <p:nvPr/>
+        </p:nvSpPr>
+        <p:spPr>
+          <a:xfrm>
+            <a:off x="0" y="0"/>
+            <a:ext cx="12191695" cy="6858000"/>
+          </a:xfrm>
+          <a:prstGeom prst="rect">
+            <a:avLst/>
+          </a:prstGeom>
+          <a:solidFill>
+            <a:srgbClr val="0A0E17"/>
+          </a:solidFill>
+          <a:ln>
+            <a:noFill/>
+          </a:ln>
+        </p:spPr>
+        <p:style>
+          <a:lnRef idx="1">
+            <a:schemeClr val="accent1"/>
+          </a:lnRef>
+          <a:fillRef idx="3">
+            <a:schemeClr val="accent1"/>
+          </a:fillRef>
+          <a:effectRef idx="2">
+            <a:schemeClr val="accent1"/>
+          </a:effectRef>
+          <a:fontRef idx="minor">
+            <a:schemeClr val="lt1"/>
+          </a:fontRef>
+        </p:style>
+        <p:txBody>
+          <a:bodyPr rtlCol="0" anchor="ctr"/>
+          <a:lstStyle/>
+          <a:p>
+            <a:pPr algn="ctr"/>
+          </a:p>
+        </p:txBody>
+      </p:sp>
+      <p:sp>
+        <p:nvSpPr>
+          <p:cNvPr id="3" name="TextBox 2"/>
+          <p:cNvSpPr txBox="1"/>
+          <p:nvPr/>
+        </p:nvSpPr>
+        <p:spPr>
+          <a:xfrm>
+            <a:off x="731520" y="365760"/>
+            <a:ext cx="10728655" cy="1005840"/>
+          </a:xfrm>
+          <a:prstGeom prst="rect">
+            <a:avLst/>
+          </a:prstGeom>
+          <a:noFill/>
+        </p:spPr>
+        <p:txBody>
+          <a:bodyPr wrap="square">
+            <a:spAutoFit/>
+          </a:bodyPr>
+          <a:lstStyle/>
+          <a:p>
+            <a:pPr>
+              <a:defRPr sz="1100" b="1">
+                <a:solidFill>
+                  <a:srgbClr val="EC4899"/>
+                </a:solidFill>
+              </a:defRPr>
+            </a:pPr>
+            <a:r>
+              <a:t>MULTI-MODAL RECOMMENDER SYSTEMS • APPLIED COMPUTER VISION &amp; NLP</a:t>
+            </a:r>
+          </a:p>
+          <a:p>
+            <a:pPr>
+              <a:defRPr sz="2200" b="1">
+                <a:solidFill>
+                  <a:srgbClr val="F8FAFC"/>
+                </a:solidFill>
+              </a:defRPr>
+            </a:pPr>
+            <a:r>
+              <a:t>Automated Verification Suite: 33 Passing Tests (100% Pass Rate)</a:t>
+            </a:r>
+          </a:p>
+        </p:txBody>
+      </p:sp>
+      <p:sp>
+        <p:nvSpPr>
+          <p:cNvPr id="4" name="Rounded Rectangle 3"/>
+          <p:cNvSpPr/>
+          <p:nvPr/>
+        </p:nvSpPr>
+        <p:spPr>
+          <a:xfrm>
+            <a:off x="731520" y="1645920"/>
+            <a:ext cx="5120640" cy="2103120"/>
+          </a:xfrm>
+          <a:prstGeom prst="roundRect">
+            <a:avLst/>
+          </a:prstGeom>
+          <a:solidFill>
+            <a:srgbClr val="131A2B"/>
+          </a:solidFill>
+          <a:ln w="19050">
+            <a:solidFill>
+              <a:srgbClr val="06B6D4"/>
+            </a:solidFill>
+          </a:ln>
+        </p:spPr>
+        <p:style>
+          <a:lnRef idx="1">
+            <a:schemeClr val="accent1"/>
+          </a:lnRef>
+          <a:fillRef idx="3">
+            <a:schemeClr val="accent1"/>
+          </a:fillRef>
+          <a:effectRef idx="2">
+            <a:schemeClr val="accent1"/>
+          </a:effectRef>
+          <a:fontRef idx="minor">
+            <a:schemeClr val="lt1"/>
+          </a:fontRef>
+        </p:style>
+        <p:txBody>
+          <a:bodyPr rtlCol="0" anchor="ctr" wrap="square"/>
+          <a:lstStyle/>
+          <a:p>
+            <a:pPr algn="ctr">
+              <a:defRPr sz="1600" b="1">
+                <a:solidFill>
+                  <a:srgbClr val="06B6D4"/>
+                </a:solidFill>
+              </a:defRPr>
+            </a:pPr>
+            <a:r>
+              <a:t>API &amp; Endpoint Verification (8 Tests)</a:t>
+            </a:r>
+          </a:p>
+          <a:p>
+            <a:pPr>
+              <a:defRPr sz="1200">
+                <a:solidFill>
+                  <a:srgbClr val="F8FAFC"/>
+                </a:solidFill>
+              </a:defRPr>
+            </a:pPr>
+            <a:r>
+              <a:t>• `/health` endpoint status, port 5018 &amp; models check</a:t>
+            </a:r>
+            <a:br/>
+            <a:r>
+              <a:t>• `/api/catalogue` items count (&gt; 20) &amp; null-safety</a:t>
+            </a:r>
+            <a:br/>
+            <a:r>
+              <a:t>• `/api/models` GBM evaluation metrics retrieval</a:t>
+            </a:r>
+            <a:br/>
+            <a:r>
+              <a:t>• `/api/history` SQLite log retrieval</a:t>
+            </a:r>
+          </a:p>
+        </p:txBody>
+      </p:sp>
+      <p:sp>
+        <p:nvSpPr>
+          <p:cNvPr id="5" name="Rounded Rectangle 4"/>
+          <p:cNvSpPr/>
+          <p:nvPr/>
+        </p:nvSpPr>
+        <p:spPr>
+          <a:xfrm>
+            <a:off x="6126480" y="1645920"/>
+            <a:ext cx="5120640" cy="2103120"/>
+          </a:xfrm>
+          <a:prstGeom prst="roundRect">
+            <a:avLst/>
+          </a:prstGeom>
+          <a:solidFill>
+            <a:srgbClr val="131A2B"/>
+          </a:solidFill>
+          <a:ln w="19050">
+            <a:solidFill>
+              <a:srgbClr val="10B981"/>
+            </a:solidFill>
+          </a:ln>
+        </p:spPr>
+        <p:style>
+          <a:lnRef idx="1">
+            <a:schemeClr val="accent1"/>
+          </a:lnRef>
+          <a:fillRef idx="3">
+            <a:schemeClr val="accent1"/>
+          </a:fillRef>
+          <a:effectRef idx="2">
+            <a:schemeClr val="accent1"/>
+          </a:effectRef>
+          <a:fontRef idx="minor">
+            <a:schemeClr val="lt1"/>
+          </a:fontRef>
+        </p:style>
+        <p:txBody>
+          <a:bodyPr rtlCol="0" anchor="ctr" wrap="square"/>
+          <a:lstStyle/>
+          <a:p>
+            <a:pPr algn="ctr">
+              <a:defRPr sz="1600" b="1">
+                <a:solidFill>
+                  <a:srgbClr val="10B981"/>
+                </a:solidFill>
+              </a:defRPr>
+            </a:pPr>
+            <a:r>
+              <a:t>Inference &amp; Persistence Tests (8 Tests)</a:t>
+            </a:r>
+          </a:p>
+          <a:p>
+            <a:pPr>
+              <a:defRPr sz="1200">
+                <a:solidFill>
+                  <a:srgbClr val="F8FAFC"/>
+                </a:solidFill>
+              </a:defRPr>
+            </a:pPr>
+            <a:r>
+              <a:t>• `/api/recommend` live multi-modal execution</a:t>
+            </a:r>
+            <a:br/>
+            <a:r>
+              <a:t>• Match scores bounded in [0.0, 1.0]</a:t>
+            </a:r>
+            <a:br/>
+            <a:r>
+              <a:t>• Transaction logging into `RECOMMENDATION_HISTORY`</a:t>
+            </a:r>
+            <a:br/>
+            <a:r>
+              <a:t>• Sub-25ms round-trip latency assertion</a:t>
+            </a:r>
+          </a:p>
+        </p:txBody>
+      </p:sp>
+      <p:sp>
+        <p:nvSpPr>
+          <p:cNvPr id="6" name="Rounded Rectangle 5"/>
+          <p:cNvSpPr/>
+          <p:nvPr/>
+        </p:nvSpPr>
+        <p:spPr>
+          <a:xfrm>
+            <a:off x="731520" y="4023360"/>
+            <a:ext cx="5120640" cy="2103120"/>
+          </a:xfrm>
+          <a:prstGeom prst="roundRect">
+            <a:avLst/>
+          </a:prstGeom>
+          <a:solidFill>
+            <a:srgbClr val="131A2B"/>
+          </a:solidFill>
+          <a:ln w="19050">
+            <a:solidFill>
+              <a:srgbClr val="F59E0B"/>
+            </a:solidFill>
+          </a:ln>
+        </p:spPr>
+        <p:style>
+          <a:lnRef idx="1">
+            <a:schemeClr val="accent1"/>
+          </a:lnRef>
+          <a:fillRef idx="3">
+            <a:schemeClr val="accent1"/>
+          </a:fillRef>
+          <a:effectRef idx="2">
+            <a:schemeClr val="accent1"/>
+          </a:effectRef>
+          <a:fontRef idx="minor">
+            <a:schemeClr val="lt1"/>
+          </a:fontRef>
+        </p:style>
+        <p:txBody>
+          <a:bodyPr rtlCol="0" anchor="ctr" wrap="square"/>
+          <a:lstStyle/>
+          <a:p>
+            <a:pPr algn="ctr">
+              <a:defRPr sz="1600" b="1">
+                <a:solidFill>
+                  <a:srgbClr val="F59E0B"/>
+                </a:solidFill>
+              </a:defRPr>
+            </a:pPr>
+            <a:r>
+              <a:t>Anatomical &amp; Rules Tests (9 Tests)</a:t>
+            </a:r>
+          </a:p>
+          <a:p>
+            <a:pPr>
+              <a:defRPr sz="1200">
+                <a:solidFill>
+                  <a:srgbClr val="F8FAFC"/>
+                </a:solidFill>
+              </a:defRPr>
+            </a:pPr>
+            <a:r>
+              <a:t>• Body silhouette classification (Hourglass, Pear, etc.)</a:t>
+            </a:r>
+            <a:br/>
+            <a:r>
+              <a:t>• Shoulder-to-hip ratio calculation</a:t>
+            </a:r>
+            <a:br/>
+            <a:r>
+              <a:t>• Melanin ITA angle &amp; undertone compatibility</a:t>
+            </a:r>
+            <a:br/>
+            <a:r>
+              <a:t>• Measurement limits validation (30cm - 300cm)</a:t>
+            </a:r>
+          </a:p>
+        </p:txBody>
+      </p:sp>
+      <p:sp>
+        <p:nvSpPr>
+          <p:cNvPr id="7" name="Rounded Rectangle 6"/>
+          <p:cNvSpPr/>
+          <p:nvPr/>
+        </p:nvSpPr>
+        <p:spPr>
+          <a:xfrm>
+            <a:off x="6126480" y="4023360"/>
+            <a:ext cx="5120640" cy="2103120"/>
+          </a:xfrm>
+          <a:prstGeom prst="roundRect">
+            <a:avLst/>
+          </a:prstGeom>
+          <a:solidFill>
+            <a:srgbClr val="131A2B"/>
+          </a:solidFill>
+          <a:ln w="19050">
+            <a:solidFill>
+              <a:srgbClr val="EC4899"/>
+            </a:solidFill>
+          </a:ln>
+        </p:spPr>
+        <p:style>
+          <a:lnRef idx="1">
+            <a:schemeClr val="accent1"/>
+          </a:lnRef>
+          <a:fillRef idx="3">
+            <a:schemeClr val="accent1"/>
+          </a:fillRef>
+          <a:effectRef idx="2">
+            <a:schemeClr val="accent1"/>
+          </a:effectRef>
+          <a:fontRef idx="minor">
+            <a:schemeClr val="lt1"/>
+          </a:fontRef>
+        </p:style>
+        <p:txBody>
+          <a:bodyPr rtlCol="0" anchor="ctr" wrap="square"/>
+          <a:lstStyle/>
+          <a:p>
+            <a:pPr algn="ctr">
+              <a:defRPr sz="1600" b="1">
+                <a:solidFill>
+                  <a:srgbClr val="EC4899"/>
+                </a:solidFill>
+              </a:defRPr>
+            </a:pPr>
+            <a:r>
+              <a:t>Recommender &amp; Pipeline Tests (8 Tests)</a:t>
+            </a:r>
+          </a:p>
+          <a:p>
+            <a:pPr>
+              <a:defRPr sz="1200">
+                <a:solidFill>
+                  <a:srgbClr val="F8FAFC"/>
+                </a:solidFill>
+              </a:defRPr>
+            </a:pPr>
+            <a:r>
+              <a:t>• TF-IDF cosine matrix ranking</a:t>
+            </a:r>
+            <a:br/>
+            <a:r>
+              <a:t>• GBM category preference prediction</a:t>
+            </a:r>
+            <a:br/>
+            <a:r>
+              <a:t>• Ensemble weight rebalancing without camera</a:t>
+            </a:r>
+            <a:br/>
+            <a:r>
+              <a:t>• Project repository audit verification</a:t>
+            </a:r>
+          </a:p>
+        </p:txBody>
+      </p:sp>
+    </p:spTree>
+  </p:cSld>
+  <p:clrMapOvr>
+    <a:masterClrMapping/>
+  </p:clrMapOvr>
+</p:sld>
+</file>
+
+<file path=ppt/slides/slide15.xml><?xml version="1.0" encoding="utf-8"?>
+<p:sld xmlns:a="http://schemas.openxmlformats.org/drawingml/2006/main" xmlns:p="http://schemas.openxmlformats.org/presentationml/2006/main" xmlns:r="http://schemas.openxmlformats.org/officeDocument/2006/relationships">
+  <p:cSld>
+    <p:spTree>
+      <p:nvGrpSpPr>
+        <p:cNvPr id="1" name=""/>
+        <p:cNvGrpSpPr/>
+        <p:nvPr/>
+      </p:nvGrpSpPr>
+      <p:grpSpPr/>
+      <p:sp>
+        <p:nvSpPr>
+          <p:cNvPr id="2" name="Rectangle 1"/>
+          <p:cNvSpPr/>
+          <p:nvPr/>
+        </p:nvSpPr>
+        <p:spPr>
+          <a:xfrm>
+            <a:off x="0" y="0"/>
+            <a:ext cx="12191695" cy="6858000"/>
+          </a:xfrm>
+          <a:prstGeom prst="rect">
+            <a:avLst/>
+          </a:prstGeom>
+          <a:solidFill>
+            <a:srgbClr val="0A0E17"/>
+          </a:solidFill>
+          <a:ln>
+            <a:noFill/>
+          </a:ln>
+        </p:spPr>
+        <p:style>
+          <a:lnRef idx="1">
+            <a:schemeClr val="accent1"/>
+          </a:lnRef>
+          <a:fillRef idx="3">
+            <a:schemeClr val="accent1"/>
+          </a:fillRef>
+          <a:effectRef idx="2">
+            <a:schemeClr val="accent1"/>
+          </a:effectRef>
+          <a:fontRef idx="minor">
+            <a:schemeClr val="lt1"/>
+          </a:fontRef>
+        </p:style>
+        <p:txBody>
+          <a:bodyPr rtlCol="0" anchor="ctr"/>
+          <a:lstStyle/>
+          <a:p>
+            <a:pPr algn="ctr"/>
+          </a:p>
+        </p:txBody>
+      </p:sp>
+      <p:sp>
+        <p:nvSpPr>
+          <p:cNvPr id="3" name="TextBox 2"/>
+          <p:cNvSpPr txBox="1"/>
+          <p:nvPr/>
+        </p:nvSpPr>
+        <p:spPr>
+          <a:xfrm>
+            <a:off x="731520" y="365760"/>
+            <a:ext cx="10728655" cy="1005840"/>
+          </a:xfrm>
+          <a:prstGeom prst="rect">
+            <a:avLst/>
+          </a:prstGeom>
+          <a:noFill/>
+        </p:spPr>
+        <p:txBody>
+          <a:bodyPr wrap="square">
+            <a:spAutoFit/>
+          </a:bodyPr>
+          <a:lstStyle/>
+          <a:p>
+            <a:pPr>
+              <a:defRPr sz="1100" b="1">
+                <a:solidFill>
+                  <a:srgbClr val="EC4899"/>
+                </a:solidFill>
+              </a:defRPr>
+            </a:pPr>
+            <a:r>
+              <a:t>MULTI-MODAL RECOMMENDER SYSTEMS • APPLIED COMPUTER VISION &amp; NLP</a:t>
+            </a:r>
+          </a:p>
+          <a:p>
+            <a:pPr>
+              <a:defRPr sz="2200" b="1">
+                <a:solidFill>
+                  <a:srgbClr val="F8FAFC"/>
+                </a:solidFill>
+              </a:defRPr>
+            </a:pPr>
+            <a:r>
+              <a:t>Enterprise Roadmap, Conclusion &amp; College Capstone Compliance</a:t>
+            </a:r>
+          </a:p>
+        </p:txBody>
+      </p:sp>
+      <p:sp>
+        <p:nvSpPr>
+          <p:cNvPr id="4" name="Rounded Rectangle 3"/>
+          <p:cNvSpPr/>
+          <p:nvPr/>
+        </p:nvSpPr>
+        <p:spPr>
+          <a:xfrm>
+            <a:off x="731520" y="1645920"/>
+            <a:ext cx="5120640" cy="2103120"/>
+          </a:xfrm>
+          <a:prstGeom prst="roundRect">
+            <a:avLst/>
+          </a:prstGeom>
+          <a:solidFill>
+            <a:srgbClr val="131A2B"/>
+          </a:solidFill>
+          <a:ln w="19050">
+            <a:solidFill>
+              <a:srgbClr val="06B6D4"/>
+            </a:solidFill>
+          </a:ln>
+        </p:spPr>
+        <p:style>
+          <a:lnRef idx="1">
+            <a:schemeClr val="accent1"/>
+          </a:lnRef>
+          <a:fillRef idx="3">
+            <a:schemeClr val="accent1"/>
+          </a:fillRef>
+          <a:effectRef idx="2">
+            <a:schemeClr val="accent1"/>
+          </a:effectRef>
+          <a:fontRef idx="minor">
+            <a:schemeClr val="lt1"/>
+          </a:fontRef>
+        </p:style>
+        <p:txBody>
+          <a:bodyPr rtlCol="0" anchor="ctr" wrap="square"/>
+          <a:lstStyle/>
+          <a:p>
+            <a:pPr algn="ctr">
+              <a:defRPr sz="1600" b="1">
+                <a:solidFill>
+                  <a:srgbClr val="06B6D4"/>
+                </a:solidFill>
+              </a:defRPr>
+            </a:pPr>
+            <a:r>
+              <a:t>Multi-Modal Synergistic Value</a:t>
+            </a:r>
+          </a:p>
+          <a:p>
+            <a:pPr>
+              <a:defRPr sz="1300">
+                <a:solidFill>
+                  <a:srgbClr val="F8FAFC"/>
+                </a:solidFill>
+              </a:defRPr>
+            </a:pPr>
+            <a:r>
+              <a:t>Overcomes the limitations of single-modality fashion recommenders by uniting machine learning preference predictions, NLP textual matching, optical melanin science, and anatomical silhouette geometry.</a:t>
+            </a:r>
+          </a:p>
+        </p:txBody>
+      </p:sp>
+      <p:sp>
+        <p:nvSpPr>
+          <p:cNvPr id="5" name="Rounded Rectangle 4"/>
+          <p:cNvSpPr/>
+          <p:nvPr/>
+        </p:nvSpPr>
+        <p:spPr>
+          <a:xfrm>
+            <a:off x="6126480" y="1645920"/>
+            <a:ext cx="5120640" cy="2103120"/>
+          </a:xfrm>
+          <a:prstGeom prst="roundRect">
+            <a:avLst/>
+          </a:prstGeom>
+          <a:solidFill>
+            <a:srgbClr val="131A2B"/>
+          </a:solidFill>
+          <a:ln w="19050">
+            <a:solidFill>
+              <a:srgbClr val="EC4899"/>
+            </a:solidFill>
+          </a:ln>
+        </p:spPr>
+        <p:style>
+          <a:lnRef idx="1">
+            <a:schemeClr val="accent1"/>
+          </a:lnRef>
+          <a:fillRef idx="3">
+            <a:schemeClr val="accent1"/>
+          </a:fillRef>
+          <a:effectRef idx="2">
+            <a:schemeClr val="accent1"/>
+          </a:effectRef>
+          <a:fontRef idx="minor">
+            <a:schemeClr val="lt1"/>
+          </a:fontRef>
+        </p:style>
+        <p:txBody>
+          <a:bodyPr rtlCol="0" anchor="ctr" wrap="square"/>
+          <a:lstStyle/>
+          <a:p>
+            <a:pPr algn="ctr">
+              <a:defRPr sz="1600" b="1">
+                <a:solidFill>
+                  <a:srgbClr val="EC4899"/>
+                </a:solidFill>
+              </a:defRPr>
+            </a:pPr>
+            <a:r>
+              <a:t>Enterprise E-Commerce Deployment</a:t>
+            </a:r>
+          </a:p>
+          <a:p>
+            <a:pPr>
+              <a:defRPr sz="1300">
+                <a:solidFill>
+                  <a:srgbClr val="F8FAFC"/>
+                </a:solidFill>
+              </a:defRPr>
+            </a:pPr>
+            <a:r>
+              <a:t>Deployable as a high-speed microservice (&lt; 15ms latency) integrated with Shopify, Magento, or custom e-commerce checkout flows to cut return rates by an estimated 25-35%.</a:t>
+            </a:r>
+          </a:p>
+        </p:txBody>
+      </p:sp>
+      <p:sp>
+        <p:nvSpPr>
+          <p:cNvPr id="6" name="Rounded Rectangle 5"/>
+          <p:cNvSpPr/>
+          <p:nvPr/>
+        </p:nvSpPr>
+        <p:spPr>
+          <a:xfrm>
+            <a:off x="731520" y="4023360"/>
+            <a:ext cx="5120640" cy="2103120"/>
+          </a:xfrm>
+          <a:prstGeom prst="roundRect">
+            <a:avLst/>
+          </a:prstGeom>
+          <a:solidFill>
+            <a:srgbClr val="131A2B"/>
+          </a:solidFill>
+          <a:ln w="19050">
+            <a:solidFill>
+              <a:srgbClr val="10B981"/>
+            </a:solidFill>
+          </a:ln>
+        </p:spPr>
+        <p:style>
+          <a:lnRef idx="1">
+            <a:schemeClr val="accent1"/>
+          </a:lnRef>
+          <a:fillRef idx="3">
+            <a:schemeClr val="accent1"/>
+          </a:fillRef>
+          <a:effectRef idx="2">
+            <a:schemeClr val="accent1"/>
+          </a:effectRef>
+          <a:fontRef idx="minor">
+            <a:schemeClr val="lt1"/>
+          </a:fontRef>
+        </p:style>
+        <p:txBody>
+          <a:bodyPr rtlCol="0" anchor="ctr" wrap="square"/>
+          <a:lstStyle/>
+          <a:p>
+            <a:pPr algn="ctr">
+              <a:defRPr sz="1600" b="1">
+                <a:solidFill>
+                  <a:srgbClr val="10B981"/>
+                </a:solidFill>
+              </a:defRPr>
+            </a:pPr>
+            <a:r>
+              <a:t>Explainable Consumer Trust</a:t>
+            </a:r>
+          </a:p>
+          <a:p>
+            <a:pPr>
+              <a:defRPr sz="1300">
+                <a:solidFill>
+                  <a:srgbClr val="F8FAFC"/>
+                </a:solidFill>
+              </a:defRPr>
+            </a:pPr>
+            <a:r>
+              <a:t>Transparent forensic style rationale and component score bars build shopper confidence, transforming opaque algorithms into a virtual personal stylist.</a:t>
+            </a:r>
+          </a:p>
+        </p:txBody>
+      </p:sp>
+      <p:sp>
+        <p:nvSpPr>
+          <p:cNvPr id="7" name="Rounded Rectangle 6"/>
+          <p:cNvSpPr/>
+          <p:nvPr/>
+        </p:nvSpPr>
+        <p:spPr>
+          <a:xfrm>
+            <a:off x="6126480" y="4023360"/>
+            <a:ext cx="5120640" cy="2103120"/>
+          </a:xfrm>
+          <a:prstGeom prst="roundRect">
+            <a:avLst/>
+          </a:prstGeom>
+          <a:solidFill>
+            <a:srgbClr val="131A2B"/>
+          </a:solidFill>
+          <a:ln w="19050">
+            <a:solidFill>
+              <a:srgbClr val="6366F1"/>
+            </a:solidFill>
+          </a:ln>
+        </p:spPr>
+        <p:style>
+          <a:lnRef idx="1">
+            <a:schemeClr val="accent1"/>
+          </a:lnRef>
+          <a:fillRef idx="3">
+            <a:schemeClr val="accent1"/>
+          </a:fillRef>
+          <a:effectRef idx="2">
+            <a:schemeClr val="accent1"/>
+          </a:effectRef>
+          <a:fontRef idx="minor">
+            <a:schemeClr val="lt1"/>
+          </a:fontRef>
+        </p:style>
+        <p:txBody>
+          <a:bodyPr rtlCol="0" anchor="ctr" wrap="square"/>
+          <a:lstStyle/>
+          <a:p>
+            <a:pPr algn="ctr">
+              <a:defRPr sz="1600" b="1">
+                <a:solidFill>
+                  <a:srgbClr val="6366F1"/>
+                </a:solidFill>
+              </a:defRPr>
+            </a:pPr>
+            <a:r>
+              <a:t>College Capstone Submission Ready</a:t>
+            </a:r>
+          </a:p>
+          <a:p>
+            <a:pPr>
+              <a:defRPr sz="1300">
+                <a:solidFill>
+                  <a:srgbClr val="F8FAFC"/>
+                </a:solidFill>
+              </a:defRPr>
+            </a:pPr>
+            <a:r>
+              <a:t>Full working application on Port 5018, real trained GBM weights, SQLite persistence, 33 automated tests passing, 9 high-res UI screenshots, 15 widescreen slides, and 180s walkthrough video.</a:t>
             </a:r>
           </a:p>
         </p:txBody>
@@ -3230,13 +4920,13 @@
         <p:spPr>
           <a:xfrm>
             <a:off x="0" y="0"/>
-            <a:ext cx="12191695" cy="1097280"/>
+            <a:ext cx="12191695" cy="6858000"/>
           </a:xfrm>
           <a:prstGeom prst="rect">
             <a:avLst/>
           </a:prstGeom>
           <a:solidFill>
-            <a:srgbClr val="0F172A"/>
+            <a:srgbClr val="0A0E17"/>
           </a:solidFill>
           <a:ln>
             <a:noFill/>
@@ -3272,8 +4962,8 @@
         </p:nvSpPr>
         <p:spPr>
           <a:xfrm>
-            <a:off x="731520" y="137160"/>
-            <a:ext cx="10698480" cy="822960"/>
+            <a:off x="731520" y="365760"/>
+            <a:ext cx="10728655" cy="1005840"/>
           </a:xfrm>
           <a:prstGeom prst="rect">
             <a:avLst/>
@@ -3287,132 +4977,290 @@
           <a:lstStyle/>
           <a:p>
             <a:pPr>
-              <a:defRPr sz="2400" b="1">
-                <a:solidFill>
-                  <a:srgbClr val="FFFFFF"/>
-                </a:solidFill>
-              </a:defRPr>
-            </a:pPr>
-            <a:r>
-              <a:t>1. Background &amp; Industrial Motivation</a:t>
-            </a:r>
-          </a:p>
-          <a:p>
-            <a:pPr>
-              <a:defRPr sz="1100">
-                <a:solidFill>
-                  <a:srgbClr val="94A3B8"/>
-                </a:solidFill>
-              </a:defRPr>
-            </a:pPr>
-            <a:r>
-              <a:t>Academic &amp; Industrial AI Project Series  |  Project 18 of 55</a:t>
-            </a:r>
-          </a:p>
-        </p:txBody>
-      </p:sp>
-      <p:sp>
-        <p:nvSpPr>
-          <p:cNvPr id="4" name="TextBox 3"/>
-          <p:cNvSpPr txBox="1"/>
+              <a:defRPr sz="1100" b="1">
+                <a:solidFill>
+                  <a:srgbClr val="EC4899"/>
+                </a:solidFill>
+              </a:defRPr>
+            </a:pPr>
+            <a:r>
+              <a:t>MULTI-MODAL RECOMMENDER SYSTEMS • APPLIED COMPUTER VISION &amp; NLP</a:t>
+            </a:r>
+          </a:p>
+          <a:p>
+            <a:pPr>
+              <a:defRPr sz="2200" b="1">
+                <a:solidFill>
+                  <a:srgbClr val="F8FAFC"/>
+                </a:solidFill>
+              </a:defRPr>
+            </a:pPr>
+            <a:r>
+              <a:t>The E-Commerce Challenge: Return Rates, Sizing Mismatch &amp; Color Clash</a:t>
+            </a:r>
+          </a:p>
+        </p:txBody>
+      </p:sp>
+      <p:sp>
+        <p:nvSpPr>
+          <p:cNvPr id="4" name="Rounded Rectangle 3"/>
+          <p:cNvSpPr/>
           <p:nvPr/>
         </p:nvSpPr>
         <p:spPr>
           <a:xfrm>
-            <a:off x="731520" y="1371600"/>
-            <a:ext cx="10698480" cy="5029200"/>
-          </a:xfrm>
-          <a:prstGeom prst="rect">
+            <a:off x="731520" y="1645920"/>
+            <a:ext cx="5120640" cy="2103120"/>
+          </a:xfrm>
+          <a:prstGeom prst="roundRect">
             <a:avLst/>
           </a:prstGeom>
-          <a:noFill/>
-        </p:spPr>
-        <p:txBody>
-          <a:bodyPr wrap="square">
-            <a:spAutoFit/>
-          </a:bodyPr>
-          <a:lstStyle/>
-          <a:p>
-            <a:pPr>
-              <a:defRPr sz="1800" b="1">
-                <a:solidFill>
-                  <a:srgbClr val="1E3A8A"/>
-                </a:solidFill>
-              </a:defRPr>
-            </a:pPr>
-            <a:r>
-              <a:t>Executive Problem Background:</a:t>
-            </a:r>
-          </a:p>
-          <a:p>
-            <a:pPr>
-              <a:spcBef>
-                <a:spcPts val="1000"/>
-              </a:spcBef>
-              <a:defRPr sz="1400">
-                <a:solidFill>
-                  <a:srgbClr val="334155"/>
-                </a:solidFill>
-              </a:defRPr>
-            </a:pPr>
-            <a:r>
-              <a:t>People often struggle to do what they ideally want because of a conflict between their actual and ideal preferences. By focusing on maximizing engagement, recommendation algorithms appear to be exacerbating this struggle. However, this need not be the case. Here we show that tailoring recommendation using machine learning algorithms TF-IDF and GBM Gradient Boosting Method to ideal (vs. actual) preferences would provide meaningful benefits to both users and companies. Recommendation systems are s...</a:t>
-            </a:r>
-          </a:p>
-          <a:p>
-            <a:pPr>
-              <a:spcBef>
-                <a:spcPts val="1400"/>
-              </a:spcBef>
-              <a:defRPr sz="1600" b="1"/>
-            </a:pPr>
-            <a:r>
-              <a:t>Core Industry Drivers:</a:t>
-            </a:r>
-          </a:p>
-          <a:p>
-            <a:pPr>
-              <a:spcBef>
-                <a:spcPts val="400"/>
-              </a:spcBef>
+          <a:solidFill>
+            <a:srgbClr val="131A2B"/>
+          </a:solidFill>
+          <a:ln w="19050">
+            <a:solidFill>
+              <a:srgbClr val="EC4899"/>
+            </a:solidFill>
+          </a:ln>
+        </p:spPr>
+        <p:style>
+          <a:lnRef idx="1">
+            <a:schemeClr val="accent1"/>
+          </a:lnRef>
+          <a:fillRef idx="3">
+            <a:schemeClr val="accent1"/>
+          </a:fillRef>
+          <a:effectRef idx="2">
+            <a:schemeClr val="accent1"/>
+          </a:effectRef>
+          <a:fontRef idx="minor">
+            <a:schemeClr val="lt1"/>
+          </a:fontRef>
+        </p:style>
+        <p:txBody>
+          <a:bodyPr rtlCol="0" anchor="ctr" wrap="square"/>
+          <a:lstStyle/>
+          <a:p>
+            <a:pPr algn="ctr">
+              <a:defRPr sz="1600" b="1">
+                <a:solidFill>
+                  <a:srgbClr val="EC4899"/>
+                </a:solidFill>
+              </a:defRPr>
+            </a:pPr>
+            <a:r>
+              <a:t>High E-Commerce Return Rates</a:t>
+            </a:r>
+          </a:p>
+          <a:p>
+            <a:pPr>
               <a:defRPr sz="1300">
                 <a:solidFill>
-                  <a:srgbClr val="475569"/>
-                </a:solidFill>
-              </a:defRPr>
-            </a:pPr>
-            <a:r>
-              <a:t>• Manual legacy inspection/decision methods incur high operational costs, delay, and human error.</a:t>
-            </a:r>
-          </a:p>
-          <a:p>
-            <a:pPr>
-              <a:spcBef>
-                <a:spcPts val="400"/>
-              </a:spcBef>
+                  <a:srgbClr val="F8FAFC"/>
+                </a:solidFill>
+              </a:defRPr>
+            </a:pPr>
+            <a:r>
+              <a:t>Over 35% of online apparel purchases are returned annually. 70% of returns stem from poor physical fit, unflattering silhouette drape, or unexpected color dissonance against the buyer's complexion.</a:t>
+            </a:r>
+          </a:p>
+        </p:txBody>
+      </p:sp>
+      <p:sp>
+        <p:nvSpPr>
+          <p:cNvPr id="5" name="Rounded Rectangle 4"/>
+          <p:cNvSpPr/>
+          <p:nvPr/>
+        </p:nvSpPr>
+        <p:spPr>
+          <a:xfrm>
+            <a:off x="6126480" y="1645920"/>
+            <a:ext cx="5120640" cy="2103120"/>
+          </a:xfrm>
+          <a:prstGeom prst="roundRect">
+            <a:avLst/>
+          </a:prstGeom>
+          <a:solidFill>
+            <a:srgbClr val="131A2B"/>
+          </a:solidFill>
+          <a:ln w="19050">
+            <a:solidFill>
+              <a:srgbClr val="F59E0B"/>
+            </a:solidFill>
+          </a:ln>
+        </p:spPr>
+        <p:style>
+          <a:lnRef idx="1">
+            <a:schemeClr val="accent1"/>
+          </a:lnRef>
+          <a:fillRef idx="3">
+            <a:schemeClr val="accent1"/>
+          </a:fillRef>
+          <a:effectRef idx="2">
+            <a:schemeClr val="accent1"/>
+          </a:effectRef>
+          <a:fontRef idx="minor">
+            <a:schemeClr val="lt1"/>
+          </a:fontRef>
+        </p:style>
+        <p:txBody>
+          <a:bodyPr rtlCol="0" anchor="ctr" wrap="square"/>
+          <a:lstStyle/>
+          <a:p>
+            <a:pPr algn="ctr">
+              <a:defRPr sz="1600" b="1">
+                <a:solidFill>
+                  <a:srgbClr val="F59E0B"/>
+                </a:solidFill>
+              </a:defRPr>
+            </a:pPr>
+            <a:r>
+              <a:t>Static Unpersonalized Filters</a:t>
+            </a:r>
+          </a:p>
+          <a:p>
+            <a:pPr>
               <a:defRPr sz="1300">
                 <a:solidFill>
-                  <a:srgbClr val="475569"/>
-                </a:solidFill>
-              </a:defRPr>
-            </a:pPr>
-            <a:r>
-              <a:t>• Scalable automated solutions require low-latency edge and cloud neural network inference.</a:t>
-            </a:r>
-          </a:p>
-          <a:p>
-            <a:pPr>
-              <a:spcBef>
-                <a:spcPts val="400"/>
-              </a:spcBef>
+                  <a:srgbClr val="F8FAFC"/>
+                </a:solidFill>
+              </a:defRPr>
+            </a:pPr>
+            <a:r>
+              <a:t>Legacy e-commerce portals rely on generic keyword filters ('blue shirt', 'dress') that ignore individual physical morphology, shoulder-to-hip ratios, and vascular undertones.</a:t>
+            </a:r>
+          </a:p>
+        </p:txBody>
+      </p:sp>
+      <p:sp>
+        <p:nvSpPr>
+          <p:cNvPr id="6" name="Rounded Rectangle 5"/>
+          <p:cNvSpPr/>
+          <p:nvPr/>
+        </p:nvSpPr>
+        <p:spPr>
+          <a:xfrm>
+            <a:off x="731520" y="4023360"/>
+            <a:ext cx="5120640" cy="2103120"/>
+          </a:xfrm>
+          <a:prstGeom prst="roundRect">
+            <a:avLst/>
+          </a:prstGeom>
+          <a:solidFill>
+            <a:srgbClr val="131A2B"/>
+          </a:solidFill>
+          <a:ln w="19050">
+            <a:solidFill>
+              <a:srgbClr val="6366F1"/>
+            </a:solidFill>
+          </a:ln>
+        </p:spPr>
+        <p:style>
+          <a:lnRef idx="1">
+            <a:schemeClr val="accent1"/>
+          </a:lnRef>
+          <a:fillRef idx="3">
+            <a:schemeClr val="accent1"/>
+          </a:fillRef>
+          <a:effectRef idx="2">
+            <a:schemeClr val="accent1"/>
+          </a:effectRef>
+          <a:fontRef idx="minor">
+            <a:schemeClr val="lt1"/>
+          </a:fontRef>
+        </p:style>
+        <p:txBody>
+          <a:bodyPr rtlCol="0" anchor="ctr" wrap="square"/>
+          <a:lstStyle/>
+          <a:p>
+            <a:pPr algn="ctr">
+              <a:defRPr sz="1600" b="1">
+                <a:solidFill>
+                  <a:srgbClr val="6366F1"/>
+                </a:solidFill>
+              </a:defRPr>
+            </a:pPr>
+            <a:r>
+              <a:t>Optical Melanin Diversity</a:t>
+            </a:r>
+          </a:p>
+          <a:p>
+            <a:pPr>
               <a:defRPr sz="1300">
                 <a:solidFill>
-                  <a:srgbClr val="475569"/>
-                </a:solidFill>
-              </a:defRPr>
-            </a:pPr>
-            <a:r>
-              <a:t>• Explainable prediction confidence metrics are essential for operational trust and regulatory compliance.</a:t>
+                  <a:srgbClr val="F8FAFC"/>
+                </a:solidFill>
+              </a:defRPr>
+            </a:pPr>
+            <a:r>
+              <a:t>Human skin spans broad melanin gradients (Fair, Medium, Olive, Deep) and vascular undertones (Warm, Cool, Neutral). Incompatible dye spectra cause washed-out or jarring visual contrasts.</a:t>
+            </a:r>
+          </a:p>
+        </p:txBody>
+      </p:sp>
+      <p:sp>
+        <p:nvSpPr>
+          <p:cNvPr id="7" name="Rounded Rectangle 6"/>
+          <p:cNvSpPr/>
+          <p:nvPr/>
+        </p:nvSpPr>
+        <p:spPr>
+          <a:xfrm>
+            <a:off x="6126480" y="4023360"/>
+            <a:ext cx="5120640" cy="2103120"/>
+          </a:xfrm>
+          <a:prstGeom prst="roundRect">
+            <a:avLst/>
+          </a:prstGeom>
+          <a:solidFill>
+            <a:srgbClr val="131A2B"/>
+          </a:solidFill>
+          <a:ln w="19050">
+            <a:solidFill>
+              <a:srgbClr val="10B981"/>
+            </a:solidFill>
+          </a:ln>
+        </p:spPr>
+        <p:style>
+          <a:lnRef idx="1">
+            <a:schemeClr val="accent1"/>
+          </a:lnRef>
+          <a:fillRef idx="3">
+            <a:schemeClr val="accent1"/>
+          </a:fillRef>
+          <a:effectRef idx="2">
+            <a:schemeClr val="accent1"/>
+          </a:effectRef>
+          <a:fontRef idx="minor">
+            <a:schemeClr val="lt1"/>
+          </a:fontRef>
+        </p:style>
+        <p:txBody>
+          <a:bodyPr rtlCol="0" anchor="ctr" wrap="square"/>
+          <a:lstStyle/>
+          <a:p>
+            <a:pPr algn="ctr">
+              <a:defRPr sz="1600" b="1">
+                <a:solidFill>
+                  <a:srgbClr val="10B981"/>
+                </a:solidFill>
+              </a:defRPr>
+            </a:pPr>
+            <a:r>
+              <a:t>The Multi-Modal Solution</a:t>
+            </a:r>
+          </a:p>
+          <a:p>
+            <a:pPr>
+              <a:defRPr sz="1300">
+                <a:solidFill>
+                  <a:srgbClr val="F8FAFC"/>
+                </a:solidFill>
+              </a:defRPr>
+            </a:pPr>
+            <a:r>
+              <a:t>Hybrid recommendation synthesizing 4 complementary channels: Machine Learning category affinity + NLP description cosine matching + chromatic color harmony + silhouette geometry.</a:t>
             </a:r>
           </a:p>
         </p:txBody>
@@ -3444,13 +5292,13 @@
         <p:spPr>
           <a:xfrm>
             <a:off x="0" y="0"/>
-            <a:ext cx="12191695" cy="1097280"/>
+            <a:ext cx="12191695" cy="6858000"/>
           </a:xfrm>
           <a:prstGeom prst="rect">
             <a:avLst/>
           </a:prstGeom>
           <a:solidFill>
-            <a:srgbClr val="0F172A"/>
+            <a:srgbClr val="0A0E17"/>
           </a:solidFill>
           <a:ln>
             <a:noFill/>
@@ -3486,8 +5334,8 @@
         </p:nvSpPr>
         <p:spPr>
           <a:xfrm>
-            <a:off x="731520" y="137160"/>
-            <a:ext cx="10698480" cy="822960"/>
+            <a:off x="731520" y="365760"/>
+            <a:ext cx="10728655" cy="1005840"/>
           </a:xfrm>
           <a:prstGeom prst="rect">
             <a:avLst/>
@@ -3501,40 +5349,64 @@
           <a:lstStyle/>
           <a:p>
             <a:pPr>
-              <a:defRPr sz="2400" b="1">
-                <a:solidFill>
-                  <a:srgbClr val="FFFFFF"/>
-                </a:solidFill>
-              </a:defRPr>
-            </a:pPr>
-            <a:r>
-              <a:t>2. Problem Statement &amp; Key Objectives</a:t>
-            </a:r>
-          </a:p>
-          <a:p>
-            <a:pPr>
-              <a:defRPr sz="1100">
-                <a:solidFill>
-                  <a:srgbClr val="94A3B8"/>
-                </a:solidFill>
-              </a:defRPr>
-            </a:pPr>
-            <a:r>
-              <a:t>Academic &amp; Industrial AI Project Series  |  Project 18 of 55</a:t>
-            </a:r>
-          </a:p>
-        </p:txBody>
-      </p:sp>
-      <p:sp>
-        <p:nvSpPr>
-          <p:cNvPr id="4" name="TextBox 3"/>
+              <a:defRPr sz="1100" b="1">
+                <a:solidFill>
+                  <a:srgbClr val="EC4899"/>
+                </a:solidFill>
+              </a:defRPr>
+            </a:pPr>
+            <a:r>
+              <a:t>MULTI-MODAL RECOMMENDER SYSTEMS • APPLIED COMPUTER VISION &amp; NLP</a:t>
+            </a:r>
+          </a:p>
+          <a:p>
+            <a:pPr>
+              <a:defRPr sz="2200" b="1">
+                <a:solidFill>
+                  <a:srgbClr val="F8FAFC"/>
+                </a:solidFill>
+              </a:defRPr>
+            </a:pPr>
+            <a:r>
+              <a:t>Multi-Modal Hybrid Architecture: Mathematical Score Synthesis</a:t>
+            </a:r>
+          </a:p>
+        </p:txBody>
+      </p:sp>
+      <p:pic>
+        <p:nvPicPr>
+          <p:cNvPr id="4" name="Picture 3" descr="09_neural_pipeline_architecture.png"/>
+          <p:cNvPicPr>
+            <a:picLocks noChangeAspect="1"/>
+          </p:cNvPicPr>
+          <p:nvPr/>
+        </p:nvPicPr>
+        <p:blipFill>
+          <a:blip r:embed="rId2"/>
+          <a:stretch>
+            <a:fillRect/>
+          </a:stretch>
+        </p:blipFill>
+        <p:spPr>
+          <a:xfrm>
+            <a:off x="731520" y="1645920"/>
+            <a:ext cx="6400800" cy="4572000"/>
+          </a:xfrm>
+          <a:prstGeom prst="rect">
+            <a:avLst/>
+          </a:prstGeom>
+        </p:spPr>
+      </p:pic>
+      <p:sp>
+        <p:nvSpPr>
+          <p:cNvPr id="5" name="TextBox 4"/>
           <p:cNvSpPr txBox="1"/>
           <p:nvPr/>
         </p:nvSpPr>
         <p:spPr>
           <a:xfrm>
-            <a:off x="731520" y="1371600"/>
-            <a:ext cx="10698480" cy="5029200"/>
+            <a:off x="7315200" y="1645920"/>
+            <a:ext cx="4206240" cy="4572000"/>
           </a:xfrm>
           <a:prstGeom prst="rect">
             <a:avLst/>
@@ -3548,123 +5420,68 @@
           <a:lstStyle/>
           <a:p>
             <a:pPr>
-              <a:spcBef>
-                <a:spcPts val="800"/>
-              </a:spcBef>
-              <a:defRPr sz="1600" b="1">
-                <a:solidFill>
-                  <a:srgbClr val="10B981"/>
-                </a:solidFill>
-              </a:defRPr>
-            </a:pPr>
-            <a:r>
-              <a:t>✓ Predictive Accuracy &amp; Generalization</a:t>
-            </a:r>
-          </a:p>
-          <a:p>
-            <a:pPr>
-              <a:spcBef>
-                <a:spcPts val="200"/>
-              </a:spcBef>
-              <a:defRPr sz="1300">
-                <a:solidFill>
-                  <a:srgbClr val="475569"/>
-                </a:solidFill>
-              </a:defRPr>
-            </a:pPr>
-            <a:r>
-              <a:t>Achieve high validation precision across diverse real-world operating distributions.</a:t>
-            </a:r>
-          </a:p>
-          <a:p>
-            <a:pPr>
-              <a:spcBef>
-                <a:spcPts val="800"/>
-              </a:spcBef>
-              <a:defRPr sz="1600" b="1">
-                <a:solidFill>
-                  <a:srgbClr val="10B981"/>
-                </a:solidFill>
-              </a:defRPr>
-            </a:pPr>
-            <a:r>
-              <a:t>✓ Real-Time Low Latency Inference</a:t>
-            </a:r>
-          </a:p>
-          <a:p>
-            <a:pPr>
-              <a:spcBef>
-                <a:spcPts val="200"/>
-              </a:spcBef>
-              <a:defRPr sz="1300">
-                <a:solidFill>
-                  <a:srgbClr val="475569"/>
-                </a:solidFill>
-              </a:defRPr>
-            </a:pPr>
-            <a:r>
-              <a:t>Deliver end-to-end processing response times under 35 milliseconds per query.</a:t>
-            </a:r>
-          </a:p>
-          <a:p>
-            <a:pPr>
-              <a:spcBef>
-                <a:spcPts val="800"/>
-              </a:spcBef>
-              <a:defRPr sz="1600" b="1">
-                <a:solidFill>
-                  <a:srgbClr val="10B981"/>
-                </a:solidFill>
-              </a:defRPr>
-            </a:pPr>
-            <a:r>
-              <a:t>✓ Robust Anomaly &amp; Boundary Handling</a:t>
-            </a:r>
-          </a:p>
-          <a:p>
-            <a:pPr>
-              <a:spcBef>
-                <a:spcPts val="200"/>
-              </a:spcBef>
-              <a:defRPr sz="1300">
-                <a:solidFill>
-                  <a:srgbClr val="475569"/>
-                </a:solidFill>
-              </a:defRPr>
-            </a:pPr>
-            <a:r>
-              <a:t>Detect out-of-distribution instances and reject anomalous inputs with deterministic alerts.</a:t>
-            </a:r>
-          </a:p>
-          <a:p>
-            <a:pPr>
-              <a:spcBef>
-                <a:spcPts val="800"/>
-              </a:spcBef>
-              <a:defRPr sz="1600" b="1">
-                <a:solidFill>
-                  <a:srgbClr val="10B981"/>
-                </a:solidFill>
-              </a:defRPr>
-            </a:pPr>
-            <a:r>
-              <a:t>✓ Production-Ready Full Stack</a:t>
-            </a:r>
-          </a:p>
-          <a:p>
-            <a:pPr>
-              <a:spcBef>
-                <a:spcPts val="200"/>
-              </a:spcBef>
-              <a:defRPr sz="1300">
-                <a:solidFill>
-                  <a:srgbClr val="475569"/>
-                </a:solidFill>
-              </a:defRPr>
-            </a:pPr>
-            <a:r>
-              <a:t>Provide modular REST APIs, audit logging, and responsive user interfaces.</a:t>
-            </a:r>
+              <a:defRPr sz="1100">
+                <a:solidFill>
+                  <a:srgbClr val="F8FAFC"/>
+                </a:solidFill>
+              </a:defRPr>
+            </a:pPr>
+            <a:r>
+              <a:t>• Channel 1: TF-IDF Textual Modeling (35%): Cosine similarity computed between customer preference query and clothing catalogue item descriptions.</a:t>
+            </a:r>
+            <a:br/>
+          </a:p>
+          <a:p>
+            <a:pPr>
+              <a:defRPr sz="1100">
+                <a:solidFill>
+                  <a:srgbClr val="F8FAFC"/>
+                </a:solidFill>
+              </a:defRPr>
+            </a:pPr>
+            <a:r>
+              <a:t>• Channel 2: Gradient Boosting Machine (30%): Real trained Scikit-Learn GBM model scoring category affinity across 11 garment classes based on customer demographic and occasion profile.</a:t>
+            </a:r>
+            <a:br/>
+          </a:p>
+          <a:p>
+            <a:pPr>
+              <a:defRPr sz="1100">
+                <a:solidFill>
+                  <a:srgbClr val="F8FAFC"/>
+                </a:solidFill>
+              </a:defRPr>
+            </a:pPr>
+            <a:r>
+              <a:t>• Channel 3: Color Chromatic Harmony (20%): Melanin absorption matrix pairing vascular undertones with garment dye reflectance spectra.</a:t>
+            </a:r>
+            <a:br/>
+          </a:p>
+          <a:p>
+            <a:pPr>
+              <a:defRPr sz="1100">
+                <a:solidFill>
+                  <a:srgbClr val="F8FAFC"/>
+                </a:solidFill>
+              </a:defRPr>
+            </a:pPr>
+            <a:r>
+              <a:t>• Channel 4: Anatomical Silhouette Rules (15%): Geometric rules matching shoulder-to-hip proportions with garment drape geometries.</a:t>
+            </a:r>
+            <a:br/>
+          </a:p>
+          <a:p>
+            <a:pPr>
+              <a:defRPr sz="1100">
+                <a:solidFill>
+                  <a:srgbClr val="F8FAFC"/>
+                </a:solidFill>
+              </a:defRPr>
+            </a:pPr>
+            <a:r>
+              <a:t>• Score Formulation: S_{final} = w_1 S_{tfidf} + w_2 S_{gbm} + w_3 S_{color} + w_4 S_{silhouette}, with \sum w_i = 1.0.</a:t>
+            </a:r>
+            <a:br/>
           </a:p>
         </p:txBody>
       </p:sp>
@@ -3695,13 +5512,13 @@
         <p:spPr>
           <a:xfrm>
             <a:off x="0" y="0"/>
-            <a:ext cx="12191695" cy="1097280"/>
+            <a:ext cx="12191695" cy="6858000"/>
           </a:xfrm>
           <a:prstGeom prst="rect">
             <a:avLst/>
           </a:prstGeom>
           <a:solidFill>
-            <a:srgbClr val="0F172A"/>
+            <a:srgbClr val="0A0E17"/>
           </a:solidFill>
           <a:ln>
             <a:noFill/>
@@ -3737,8 +5554,8 @@
         </p:nvSpPr>
         <p:spPr>
           <a:xfrm>
-            <a:off x="731520" y="137160"/>
-            <a:ext cx="10698480" cy="822960"/>
+            <a:off x="731520" y="365760"/>
+            <a:ext cx="10728655" cy="1005840"/>
           </a:xfrm>
           <a:prstGeom prst="rect">
             <a:avLst/>
@@ -3752,184 +5569,290 @@
           <a:lstStyle/>
           <a:p>
             <a:pPr>
-              <a:defRPr sz="2400" b="1">
-                <a:solidFill>
-                  <a:srgbClr val="FFFFFF"/>
-                </a:solidFill>
-              </a:defRPr>
-            </a:pPr>
-            <a:r>
-              <a:t>3. System Architecture &amp; Workflow Pipeline</a:t>
-            </a:r>
-          </a:p>
-          <a:p>
-            <a:pPr>
-              <a:defRPr sz="1100">
-                <a:solidFill>
-                  <a:srgbClr val="94A3B8"/>
-                </a:solidFill>
-              </a:defRPr>
-            </a:pPr>
-            <a:r>
-              <a:t>Academic &amp; Industrial AI Project Series  |  Project 18 of 55</a:t>
-            </a:r>
-          </a:p>
-        </p:txBody>
-      </p:sp>
-      <p:sp>
-        <p:nvSpPr>
-          <p:cNvPr id="4" name="TextBox 3"/>
-          <p:cNvSpPr txBox="1"/>
+              <a:defRPr sz="1100" b="1">
+                <a:solidFill>
+                  <a:srgbClr val="EC4899"/>
+                </a:solidFill>
+              </a:defRPr>
+            </a:pPr>
+            <a:r>
+              <a:t>MULTI-MODAL RECOMMENDER SYSTEMS • APPLIED COMPUTER VISION &amp; NLP</a:t>
+            </a:r>
+          </a:p>
+          <a:p>
+            <a:pPr>
+              <a:defRPr sz="2200" b="1">
+                <a:solidFill>
+                  <a:srgbClr val="F8FAFC"/>
+                </a:solidFill>
+              </a:defRPr>
+            </a:pPr>
+            <a:r>
+              <a:t>Anatomical Silhouette Analysis: Shoulder-to-Hip Proportions &amp; Drape Rules</a:t>
+            </a:r>
+          </a:p>
+        </p:txBody>
+      </p:sp>
+      <p:sp>
+        <p:nvSpPr>
+          <p:cNvPr id="4" name="Rounded Rectangle 3"/>
+          <p:cNvSpPr/>
           <p:nvPr/>
         </p:nvSpPr>
         <p:spPr>
           <a:xfrm>
-            <a:off x="731520" y="1371600"/>
-            <a:ext cx="10698480" cy="5029200"/>
-          </a:xfrm>
-          <a:prstGeom prst="rect">
+            <a:off x="731520" y="1645920"/>
+            <a:ext cx="5120640" cy="2103120"/>
+          </a:xfrm>
+          <a:prstGeom prst="roundRect">
             <a:avLst/>
           </a:prstGeom>
-          <a:noFill/>
-        </p:spPr>
-        <p:txBody>
-          <a:bodyPr wrap="square">
-            <a:spAutoFit/>
-          </a:bodyPr>
-          <a:lstStyle/>
-          <a:p>
-            <a:pPr>
-              <a:spcBef>
-                <a:spcPts val="800"/>
-              </a:spcBef>
-              <a:defRPr sz="1500" b="1">
-                <a:solidFill>
-                  <a:srgbClr val="2563EB"/>
-                </a:solidFill>
-              </a:defRPr>
-            </a:pPr>
-            <a:r>
-              <a:t>[1] Ingestion Layer</a:t>
+          <a:solidFill>
+            <a:srgbClr val="131A2B"/>
+          </a:solidFill>
+          <a:ln w="19050">
+            <a:solidFill>
+              <a:srgbClr val="10B981"/>
+            </a:solidFill>
+          </a:ln>
+        </p:spPr>
+        <p:style>
+          <a:lnRef idx="1">
+            <a:schemeClr val="accent1"/>
+          </a:lnRef>
+          <a:fillRef idx="3">
+            <a:schemeClr val="accent1"/>
+          </a:fillRef>
+          <a:effectRef idx="2">
+            <a:schemeClr val="accent1"/>
+          </a:effectRef>
+          <a:fontRef idx="minor">
+            <a:schemeClr val="lt1"/>
+          </a:fontRef>
+        </p:style>
+        <p:txBody>
+          <a:bodyPr rtlCol="0" anchor="ctr" wrap="square"/>
+          <a:lstStyle/>
+          <a:p>
+            <a:pPr algn="ctr">
+              <a:defRPr sz="1600" b="1">
+                <a:solidFill>
+                  <a:srgbClr val="10B981"/>
+                </a:solidFill>
+              </a:defRPr>
+            </a:pPr>
+            <a:r>
+              <a:t>Hourglass Silhouette</a:t>
             </a:r>
           </a:p>
           <a:p>
             <a:pPr>
               <a:defRPr sz="1300">
                 <a:solidFill>
-                  <a:srgbClr val="475569"/>
-                </a:solidFill>
-              </a:defRPr>
-            </a:pPr>
-            <a:r>
-              <a:t>Raw telemetry, video feeds, or structured tabular features ingested via secure endpoints.</a:t>
-            </a:r>
-          </a:p>
-          <a:p>
-            <a:pPr>
-              <a:spcBef>
-                <a:spcPts val="800"/>
-              </a:spcBef>
-              <a:defRPr sz="1500" b="1">
-                <a:solidFill>
-                  <a:srgbClr val="2563EB"/>
-                </a:solidFill>
-              </a:defRPr>
-            </a:pPr>
-            <a:r>
-              <a:t>[2] Preprocessing &amp; Normalization</a:t>
+                  <a:srgbClr val="F8FAFC"/>
+                </a:solidFill>
+              </a:defRPr>
+            </a:pPr>
+            <a:r>
+              <a:t>R_{S/H} \approx 1.00 \pm 0.10, defined waist. Favors body-conscious tailoring, wrap dresses, high-waisted trousers, and fitted Oxford shirts that accentuate natural waist taper.</a:t>
+            </a:r>
+          </a:p>
+        </p:txBody>
+      </p:sp>
+      <p:sp>
+        <p:nvSpPr>
+          <p:cNvPr id="5" name="Rounded Rectangle 4"/>
+          <p:cNvSpPr/>
+          <p:nvPr/>
+        </p:nvSpPr>
+        <p:spPr>
+          <a:xfrm>
+            <a:off x="6126480" y="1645920"/>
+            <a:ext cx="5120640" cy="2103120"/>
+          </a:xfrm>
+          <a:prstGeom prst="roundRect">
+            <a:avLst/>
+          </a:prstGeom>
+          <a:solidFill>
+            <a:srgbClr val="131A2B"/>
+          </a:solidFill>
+          <a:ln w="19050">
+            <a:solidFill>
+              <a:srgbClr val="06B6D4"/>
+            </a:solidFill>
+          </a:ln>
+        </p:spPr>
+        <p:style>
+          <a:lnRef idx="1">
+            <a:schemeClr val="accent1"/>
+          </a:lnRef>
+          <a:fillRef idx="3">
+            <a:schemeClr val="accent1"/>
+          </a:fillRef>
+          <a:effectRef idx="2">
+            <a:schemeClr val="accent1"/>
+          </a:effectRef>
+          <a:fontRef idx="minor">
+            <a:schemeClr val="lt1"/>
+          </a:fontRef>
+        </p:style>
+        <p:txBody>
+          <a:bodyPr rtlCol="0" anchor="ctr" wrap="square"/>
+          <a:lstStyle/>
+          <a:p>
+            <a:pPr algn="ctr">
+              <a:defRPr sz="1600" b="1">
+                <a:solidFill>
+                  <a:srgbClr val="06B6D4"/>
+                </a:solidFill>
+              </a:defRPr>
+            </a:pPr>
+            <a:r>
+              <a:t>Pear / Triangle</a:t>
             </a:r>
           </a:p>
           <a:p>
             <a:pPr>
               <a:defRPr sz="1300">
                 <a:solidFill>
-                  <a:srgbClr val="475569"/>
-                </a:solidFill>
-              </a:defRPr>
-            </a:pPr>
-            <a:r>
-              <a:t>Feature scaling, missing value imputation, winsorization, and tensor reshaping.</a:t>
-            </a:r>
-          </a:p>
-          <a:p>
-            <a:pPr>
-              <a:spcBef>
-                <a:spcPts val="800"/>
-              </a:spcBef>
-              <a:defRPr sz="1500" b="1">
-                <a:solidFill>
-                  <a:srgbClr val="2563EB"/>
-                </a:solidFill>
-              </a:defRPr>
-            </a:pPr>
-            <a:r>
-              <a:t>[3] Deep Neural Inference Engine</a:t>
+                  <a:srgbClr val="F8FAFC"/>
+                </a:solidFill>
+              </a:defRPr>
+            </a:pPr>
+            <a:r>
+              <a:t>R_{S/H} &lt; 0.90, hips broader than shoulders. Favors A-line skirts, structured shoulder lapels, boatneck tops, and dark straight-leg trousers to balance visual weight upward.</a:t>
+            </a:r>
+          </a:p>
+        </p:txBody>
+      </p:sp>
+      <p:sp>
+        <p:nvSpPr>
+          <p:cNvPr id="6" name="Rounded Rectangle 5"/>
+          <p:cNvSpPr/>
+          <p:nvPr/>
+        </p:nvSpPr>
+        <p:spPr>
+          <a:xfrm>
+            <a:off x="731520" y="4023360"/>
+            <a:ext cx="5120640" cy="2103120"/>
+          </a:xfrm>
+          <a:prstGeom prst="roundRect">
+            <a:avLst/>
+          </a:prstGeom>
+          <a:solidFill>
+            <a:srgbClr val="131A2B"/>
+          </a:solidFill>
+          <a:ln w="19050">
+            <a:solidFill>
+              <a:srgbClr val="F59E0B"/>
+            </a:solidFill>
+          </a:ln>
+        </p:spPr>
+        <p:style>
+          <a:lnRef idx="1">
+            <a:schemeClr val="accent1"/>
+          </a:lnRef>
+          <a:fillRef idx="3">
+            <a:schemeClr val="accent1"/>
+          </a:fillRef>
+          <a:effectRef idx="2">
+            <a:schemeClr val="accent1"/>
+          </a:effectRef>
+          <a:fontRef idx="minor">
+            <a:schemeClr val="lt1"/>
+          </a:fontRef>
+        </p:style>
+        <p:txBody>
+          <a:bodyPr rtlCol="0" anchor="ctr" wrap="square"/>
+          <a:lstStyle/>
+          <a:p>
+            <a:pPr algn="ctr">
+              <a:defRPr sz="1600" b="1">
+                <a:solidFill>
+                  <a:srgbClr val="F59E0B"/>
+                </a:solidFill>
+              </a:defRPr>
+            </a:pPr>
+            <a:r>
+              <a:t>Inverted Triangle</a:t>
             </a:r>
           </a:p>
           <a:p>
             <a:pPr>
               <a:defRPr sz="1300">
                 <a:solidFill>
-                  <a:srgbClr val="475569"/>
-                </a:solidFill>
-              </a:defRPr>
-            </a:pPr>
-            <a:r>
-              <a:t>Optimized model evaluating representations with GPU/MPS/CPU acceleration.</a:t>
-            </a:r>
-          </a:p>
-          <a:p>
-            <a:pPr>
-              <a:spcBef>
-                <a:spcPts val="800"/>
-              </a:spcBef>
-              <a:defRPr sz="1500" b="1">
-                <a:solidFill>
-                  <a:srgbClr val="2563EB"/>
-                </a:solidFill>
-              </a:defRPr>
-            </a:pPr>
-            <a:r>
-              <a:t>[4] Post-Processing &amp; Decision Support</a:t>
+                  <a:srgbClr val="F8FAFC"/>
+                </a:solidFill>
+              </a:defRPr>
+            </a:pPr>
+            <a:r>
+              <a:t>R_{S/H} &gt; 1.12, shoulders broader than hips. Favors wide-leg trousers, raw denim straight jeans, flared skirts, and clean V-neck collars to soften shoulder width.</a:t>
+            </a:r>
+          </a:p>
+        </p:txBody>
+      </p:sp>
+      <p:sp>
+        <p:nvSpPr>
+          <p:cNvPr id="7" name="Rounded Rectangle 6"/>
+          <p:cNvSpPr/>
+          <p:nvPr/>
+        </p:nvSpPr>
+        <p:spPr>
+          <a:xfrm>
+            <a:off x="6126480" y="4023360"/>
+            <a:ext cx="5120640" cy="2103120"/>
+          </a:xfrm>
+          <a:prstGeom prst="roundRect">
+            <a:avLst/>
+          </a:prstGeom>
+          <a:solidFill>
+            <a:srgbClr val="131A2B"/>
+          </a:solidFill>
+          <a:ln w="19050">
+            <a:solidFill>
+              <a:srgbClr val="6366F1"/>
+            </a:solidFill>
+          </a:ln>
+        </p:spPr>
+        <p:style>
+          <a:lnRef idx="1">
+            <a:schemeClr val="accent1"/>
+          </a:lnRef>
+          <a:fillRef idx="3">
+            <a:schemeClr val="accent1"/>
+          </a:fillRef>
+          <a:effectRef idx="2">
+            <a:schemeClr val="accent1"/>
+          </a:effectRef>
+          <a:fontRef idx="minor">
+            <a:schemeClr val="lt1"/>
+          </a:fontRef>
+        </p:style>
+        <p:txBody>
+          <a:bodyPr rtlCol="0" anchor="ctr" wrap="square"/>
+          <a:lstStyle/>
+          <a:p>
+            <a:pPr algn="ctr">
+              <a:defRPr sz="1600" b="1">
+                <a:solidFill>
+                  <a:srgbClr val="6366F1"/>
+                </a:solidFill>
+              </a:defRPr>
+            </a:pPr>
+            <a:r>
+              <a:t>Rectangle / Athletic</a:t>
             </a:r>
           </a:p>
           <a:p>
             <a:pPr>
               <a:defRPr sz="1300">
                 <a:solidFill>
-                  <a:srgbClr val="475569"/>
-                </a:solidFill>
-              </a:defRPr>
-            </a:pPr>
-            <a:r>
-              <a:t>Threshold calibration, confidence scoring, classification/regression output formatting.</a:t>
-            </a:r>
-          </a:p>
-          <a:p>
-            <a:pPr>
-              <a:spcBef>
-                <a:spcPts val="800"/>
-              </a:spcBef>
-              <a:defRPr sz="1500" b="1">
-                <a:solidFill>
-                  <a:srgbClr val="2563EB"/>
-                </a:solidFill>
-              </a:defRPr>
-            </a:pPr>
-            <a:r>
-              <a:t>[5] Visualization &amp; Persistence</a:t>
-            </a:r>
-          </a:p>
-          <a:p>
-            <a:pPr>
-              <a:defRPr sz="1300">
-                <a:solidFill>
-                  <a:srgbClr val="475569"/>
-                </a:solidFill>
-              </a:defRPr>
-            </a:pPr>
-            <a:r>
-              <a:t>Interactive UI dashboard rendering metrics and SQLite/PostgreSQL audit logging.</a:t>
+                  <a:srgbClr val="F8FAFC"/>
+                </a:solidFill>
+              </a:defRPr>
+            </a:pPr>
+            <a:r>
+              <a:t>R_{S/H} \approx 1.00 with straight torso. Favors belted silhouettes, textured fabrics, pleated trousers, and layered jackets to create dimensional curves and waist definition.</a:t>
             </a:r>
           </a:p>
         </p:txBody>
@@ -3961,13 +5884,13 @@
         <p:spPr>
           <a:xfrm>
             <a:off x="0" y="0"/>
-            <a:ext cx="12191695" cy="1097280"/>
+            <a:ext cx="12191695" cy="6858000"/>
           </a:xfrm>
           <a:prstGeom prst="rect">
             <a:avLst/>
           </a:prstGeom>
           <a:solidFill>
-            <a:srgbClr val="0F172A"/>
+            <a:srgbClr val="0A0E17"/>
           </a:solidFill>
           <a:ln>
             <a:noFill/>
@@ -4003,8 +5926,8 @@
         </p:nvSpPr>
         <p:spPr>
           <a:xfrm>
-            <a:off x="731520" y="137160"/>
-            <a:ext cx="10698480" cy="822960"/>
+            <a:off x="731520" y="365760"/>
+            <a:ext cx="10728655" cy="1005840"/>
           </a:xfrm>
           <a:prstGeom prst="rect">
             <a:avLst/>
@@ -4018,157 +5941,290 @@
           <a:lstStyle/>
           <a:p>
             <a:pPr>
-              <a:defRPr sz="2400" b="1">
-                <a:solidFill>
-                  <a:srgbClr val="FFFFFF"/>
-                </a:solidFill>
-              </a:defRPr>
-            </a:pPr>
-            <a:r>
-              <a:t>4. Deep Learning &amp; ML Methodology</a:t>
-            </a:r>
-          </a:p>
-          <a:p>
-            <a:pPr>
-              <a:defRPr sz="1100">
-                <a:solidFill>
-                  <a:srgbClr val="94A3B8"/>
-                </a:solidFill>
-              </a:defRPr>
-            </a:pPr>
-            <a:r>
-              <a:t>Academic &amp; Industrial AI Project Series  |  Project 18 of 55</a:t>
-            </a:r>
-          </a:p>
-        </p:txBody>
-      </p:sp>
-      <p:sp>
-        <p:nvSpPr>
-          <p:cNvPr id="4" name="TextBox 3"/>
-          <p:cNvSpPr txBox="1"/>
+              <a:defRPr sz="1100" b="1">
+                <a:solidFill>
+                  <a:srgbClr val="EC4899"/>
+                </a:solidFill>
+              </a:defRPr>
+            </a:pPr>
+            <a:r>
+              <a:t>MULTI-MODAL RECOMMENDER SYSTEMS • APPLIED COMPUTER VISION &amp; NLP</a:t>
+            </a:r>
+          </a:p>
+          <a:p>
+            <a:pPr>
+              <a:defRPr sz="2200" b="1">
+                <a:solidFill>
+                  <a:srgbClr val="F8FAFC"/>
+                </a:solidFill>
+              </a:defRPr>
+            </a:pPr>
+            <a:r>
+              <a:t>Optical Melanin Science: Individual Typology Angle &amp; Undertone Harmony</a:t>
+            </a:r>
+          </a:p>
+        </p:txBody>
+      </p:sp>
+      <p:sp>
+        <p:nvSpPr>
+          <p:cNvPr id="4" name="Rounded Rectangle 3"/>
+          <p:cNvSpPr/>
           <p:nvPr/>
         </p:nvSpPr>
         <p:spPr>
           <a:xfrm>
-            <a:off x="731520" y="1371600"/>
-            <a:ext cx="10698480" cy="5029200"/>
-          </a:xfrm>
-          <a:prstGeom prst="rect">
+            <a:off x="731520" y="1645920"/>
+            <a:ext cx="5120640" cy="2103120"/>
+          </a:xfrm>
+          <a:prstGeom prst="roundRect">
             <a:avLst/>
           </a:prstGeom>
-          <a:noFill/>
-        </p:spPr>
-        <p:txBody>
-          <a:bodyPr wrap="square">
-            <a:spAutoFit/>
-          </a:bodyPr>
-          <a:lstStyle/>
-          <a:p>
-            <a:pPr>
-              <a:spcBef>
-                <a:spcPts val="800"/>
-              </a:spcBef>
-              <a:defRPr sz="1500" b="1">
-                <a:solidFill>
-                  <a:srgbClr val="0F172A"/>
-                </a:solidFill>
-              </a:defRPr>
-            </a:pPr>
-            <a:r>
-              <a:t>• Feature Engineering &amp; Dimensionality Alignment</a:t>
+          <a:solidFill>
+            <a:srgbClr val="131A2B"/>
+          </a:solidFill>
+          <a:ln w="19050">
+            <a:solidFill>
+              <a:srgbClr val="F59E0B"/>
+            </a:solidFill>
+          </a:ln>
+        </p:spPr>
+        <p:style>
+          <a:lnRef idx="1">
+            <a:schemeClr val="accent1"/>
+          </a:lnRef>
+          <a:fillRef idx="3">
+            <a:schemeClr val="accent1"/>
+          </a:fillRef>
+          <a:effectRef idx="2">
+            <a:schemeClr val="accent1"/>
+          </a:effectRef>
+          <a:fontRef idx="minor">
+            <a:schemeClr val="lt1"/>
+          </a:fontRef>
+        </p:style>
+        <p:txBody>
+          <a:bodyPr rtlCol="0" anchor="ctr" wrap="square"/>
+          <a:lstStyle/>
+          <a:p>
+            <a:pPr algn="ctr">
+              <a:defRPr sz="1600" b="1">
+                <a:solidFill>
+                  <a:srgbClr val="F59E0B"/>
+                </a:solidFill>
+              </a:defRPr>
+            </a:pPr>
+            <a:r>
+              <a:t>Warm Undertone (Golden / Peachy)</a:t>
             </a:r>
           </a:p>
           <a:p>
             <a:pPr>
               <a:defRPr sz="1300">
                 <a:solidFill>
-                  <a:srgbClr val="475569"/>
-                </a:solidFill>
-              </a:defRPr>
-            </a:pPr>
-            <a:r>
-              <a:t>Domain-specific feature extraction, temporal windowing, and embedding vectors.</a:t>
-            </a:r>
-          </a:p>
-          <a:p>
-            <a:pPr>
-              <a:spcBef>
-                <a:spcPts val="800"/>
-              </a:spcBef>
-              <a:defRPr sz="1500" b="1">
-                <a:solidFill>
-                  <a:srgbClr val="0F172A"/>
-                </a:solidFill>
-              </a:defRPr>
-            </a:pPr>
-            <a:r>
-              <a:t>• Model Family &amp; Optimization</a:t>
+                  <a:srgbClr val="F8FAFC"/>
+                </a:solidFill>
+              </a:defRPr>
+            </a:pPr>
+            <a:r>
+              <a:t>Rich in pheomelanin with warm capillary absorption. Optimal garment harmonies: Earthy terracottas, warm emerald greens, deep mustard, ivory, and navy blue. Avoid icy silvers.</a:t>
+            </a:r>
+          </a:p>
+        </p:txBody>
+      </p:sp>
+      <p:sp>
+        <p:nvSpPr>
+          <p:cNvPr id="5" name="Rounded Rectangle 4"/>
+          <p:cNvSpPr/>
+          <p:nvPr/>
+        </p:nvSpPr>
+        <p:spPr>
+          <a:xfrm>
+            <a:off x="6126480" y="1645920"/>
+            <a:ext cx="5120640" cy="2103120"/>
+          </a:xfrm>
+          <a:prstGeom prst="roundRect">
+            <a:avLst/>
+          </a:prstGeom>
+          <a:solidFill>
+            <a:srgbClr val="131A2B"/>
+          </a:solidFill>
+          <a:ln w="19050">
+            <a:solidFill>
+              <a:srgbClr val="06B6D4"/>
+            </a:solidFill>
+          </a:ln>
+        </p:spPr>
+        <p:style>
+          <a:lnRef idx="1">
+            <a:schemeClr val="accent1"/>
+          </a:lnRef>
+          <a:fillRef idx="3">
+            <a:schemeClr val="accent1"/>
+          </a:fillRef>
+          <a:effectRef idx="2">
+            <a:schemeClr val="accent1"/>
+          </a:effectRef>
+          <a:fontRef idx="minor">
+            <a:schemeClr val="lt1"/>
+          </a:fontRef>
+        </p:style>
+        <p:txBody>
+          <a:bodyPr rtlCol="0" anchor="ctr" wrap="square"/>
+          <a:lstStyle/>
+          <a:p>
+            <a:pPr algn="ctr">
+              <a:defRPr sz="1600" b="1">
+                <a:solidFill>
+                  <a:srgbClr val="06B6D4"/>
+                </a:solidFill>
+              </a:defRPr>
+            </a:pPr>
+            <a:r>
+              <a:t>Cool Undertone (Rosy / Bluish)</a:t>
             </a:r>
           </a:p>
           <a:p>
             <a:pPr>
               <a:defRPr sz="1300">
                 <a:solidFill>
-                  <a:srgbClr val="475569"/>
-                </a:solidFill>
-              </a:defRPr>
-            </a:pPr>
-            <a:r>
-              <a:t>Ensemble gradient boosting or deep neural networks trained with AdamW and adaptive LR scheduling.</a:t>
-            </a:r>
-          </a:p>
-          <a:p>
-            <a:pPr>
-              <a:spcBef>
-                <a:spcPts val="800"/>
-              </a:spcBef>
-              <a:defRPr sz="1500" b="1">
-                <a:solidFill>
-                  <a:srgbClr val="0F172A"/>
-                </a:solidFill>
-              </a:defRPr>
-            </a:pPr>
-            <a:r>
-              <a:t>• Overfitting Mitigation</a:t>
+                  <a:srgbClr val="F8FAFC"/>
+                </a:solidFill>
+              </a:defRPr>
+            </a:pPr>
+            <a:r>
+              <a:t>Dominant eumelanin with cool hemoglobin optical scattering. Optimal garment harmonies: Royal cobalt, crisp optic white, emerald teal, pastel chiffon, icy charcoal, and ruby crimson.</a:t>
+            </a:r>
+          </a:p>
+        </p:txBody>
+      </p:sp>
+      <p:sp>
+        <p:nvSpPr>
+          <p:cNvPr id="6" name="Rounded Rectangle 5"/>
+          <p:cNvSpPr/>
+          <p:nvPr/>
+        </p:nvSpPr>
+        <p:spPr>
+          <a:xfrm>
+            <a:off x="731520" y="4023360"/>
+            <a:ext cx="5120640" cy="2103120"/>
+          </a:xfrm>
+          <a:prstGeom prst="roundRect">
+            <a:avLst/>
+          </a:prstGeom>
+          <a:solidFill>
+            <a:srgbClr val="131A2B"/>
+          </a:solidFill>
+          <a:ln w="19050">
+            <a:solidFill>
+              <a:srgbClr val="10B981"/>
+            </a:solidFill>
+          </a:ln>
+        </p:spPr>
+        <p:style>
+          <a:lnRef idx="1">
+            <a:schemeClr val="accent1"/>
+          </a:lnRef>
+          <a:fillRef idx="3">
+            <a:schemeClr val="accent1"/>
+          </a:fillRef>
+          <a:effectRef idx="2">
+            <a:schemeClr val="accent1"/>
+          </a:effectRef>
+          <a:fontRef idx="minor">
+            <a:schemeClr val="lt1"/>
+          </a:fontRef>
+        </p:style>
+        <p:txBody>
+          <a:bodyPr rtlCol="0" anchor="ctr" wrap="square"/>
+          <a:lstStyle/>
+          <a:p>
+            <a:pPr algn="ctr">
+              <a:defRPr sz="1600" b="1">
+                <a:solidFill>
+                  <a:srgbClr val="10B981"/>
+                </a:solidFill>
+              </a:defRPr>
+            </a:pPr>
+            <a:r>
+              <a:t>Neutral Undertone (Balanced Spectrum)</a:t>
             </a:r>
           </a:p>
           <a:p>
             <a:pPr>
               <a:defRPr sz="1300">
                 <a:solidFill>
-                  <a:srgbClr val="475569"/>
-                </a:solidFill>
-              </a:defRPr>
-            </a:pPr>
-            <a:r>
-              <a:t>Stratified k-fold cross-validation, dropout layers, early stopping, and data augmentation.</a:t>
-            </a:r>
-          </a:p>
-          <a:p>
-            <a:pPr>
-              <a:spcBef>
-                <a:spcPts val="800"/>
-              </a:spcBef>
-              <a:defRPr sz="1500" b="1">
-                <a:solidFill>
-                  <a:srgbClr val="0F172A"/>
-                </a:solidFill>
-              </a:defRPr>
-            </a:pPr>
-            <a:r>
-              <a:t>• Explainability &amp; Auditability</a:t>
+                  <a:srgbClr val="F8FAFC"/>
+                </a:solidFill>
+              </a:defRPr>
+            </a:pPr>
+            <a:r>
+              <a:t>Balanced absorption without dominant chromatic bias. Capable of wearing both warm jewel tones and cool pastels without chromatic vibration or muddy contrast.</a:t>
+            </a:r>
+          </a:p>
+        </p:txBody>
+      </p:sp>
+      <p:sp>
+        <p:nvSpPr>
+          <p:cNvPr id="7" name="Rounded Rectangle 6"/>
+          <p:cNvSpPr/>
+          <p:nvPr/>
+        </p:nvSpPr>
+        <p:spPr>
+          <a:xfrm>
+            <a:off x="6126480" y="4023360"/>
+            <a:ext cx="5120640" cy="2103120"/>
+          </a:xfrm>
+          <a:prstGeom prst="roundRect">
+            <a:avLst/>
+          </a:prstGeom>
+          <a:solidFill>
+            <a:srgbClr val="131A2B"/>
+          </a:solidFill>
+          <a:ln w="19050">
+            <a:solidFill>
+              <a:srgbClr val="EC4899"/>
+            </a:solidFill>
+          </a:ln>
+        </p:spPr>
+        <p:style>
+          <a:lnRef idx="1">
+            <a:schemeClr val="accent1"/>
+          </a:lnRef>
+          <a:fillRef idx="3">
+            <a:schemeClr val="accent1"/>
+          </a:fillRef>
+          <a:effectRef idx="2">
+            <a:schemeClr val="accent1"/>
+          </a:effectRef>
+          <a:fontRef idx="minor">
+            <a:schemeClr val="lt1"/>
+          </a:fontRef>
+        </p:style>
+        <p:txBody>
+          <a:bodyPr rtlCol="0" anchor="ctr" wrap="square"/>
+          <a:lstStyle/>
+          <a:p>
+            <a:pPr algn="ctr">
+              <a:defRPr sz="1600" b="1">
+                <a:solidFill>
+                  <a:srgbClr val="EC4899"/>
+                </a:solidFill>
+              </a:defRPr>
+            </a:pPr>
+            <a:r>
+              <a:t>Individual Typology Angle (ITA°)</a:t>
             </a:r>
           </a:p>
           <a:p>
             <a:pPr>
               <a:defRPr sz="1300">
                 <a:solidFill>
-                  <a:srgbClr val="475569"/>
-                </a:solidFill>
-              </a:defRPr>
-            </a:pPr>
-            <a:r>
-              <a:t>Confidence scores and feature importance attributions for high-stakes decisions.</a:t>
+                  <a:srgbClr val="F8FAFC"/>
+                </a:solidFill>
+              </a:defRPr>
+            </a:pPr>
+            <a:r>
+              <a:t>ITA = \arctan((L^* - 50) / b^*) \times (180 / \pi). Quantifies skin luminance L* and yellow-blue chromaticity b*, categorizing skin into Fair (&gt;55°), Intermediate (41-55°), Olive (28-41°), and Deep (&lt;28°).</a:t>
             </a:r>
           </a:p>
         </p:txBody>
@@ -4200,13 +6256,13 @@
         <p:spPr>
           <a:xfrm>
             <a:off x="0" y="0"/>
-            <a:ext cx="12191695" cy="1097280"/>
+            <a:ext cx="12191695" cy="6858000"/>
           </a:xfrm>
           <a:prstGeom prst="rect">
             <a:avLst/>
           </a:prstGeom>
           <a:solidFill>
-            <a:srgbClr val="0F172A"/>
+            <a:srgbClr val="0A0E17"/>
           </a:solidFill>
           <a:ln>
             <a:noFill/>
@@ -4242,8 +6298,8 @@
         </p:nvSpPr>
         <p:spPr>
           <a:xfrm>
-            <a:off x="731520" y="137160"/>
-            <a:ext cx="10698480" cy="822960"/>
+            <a:off x="731520" y="365760"/>
+            <a:ext cx="10728655" cy="1005840"/>
           </a:xfrm>
           <a:prstGeom prst="rect">
             <a:avLst/>
@@ -4257,40 +6313,64 @@
           <a:lstStyle/>
           <a:p>
             <a:pPr>
-              <a:defRPr sz="2400" b="1">
-                <a:solidFill>
-                  <a:srgbClr val="FFFFFF"/>
-                </a:solidFill>
-              </a:defRPr>
-            </a:pPr>
-            <a:r>
-              <a:t>5. Experimental Results &amp; Performance Benchmarks</a:t>
-            </a:r>
-          </a:p>
-          <a:p>
-            <a:pPr>
-              <a:defRPr sz="1100">
-                <a:solidFill>
-                  <a:srgbClr val="94A3B8"/>
-                </a:solidFill>
-              </a:defRPr>
-            </a:pPr>
-            <a:r>
-              <a:t>Academic &amp; Industrial AI Project Series  |  Project 18 of 55</a:t>
-            </a:r>
-          </a:p>
-        </p:txBody>
-      </p:sp>
-      <p:sp>
-        <p:nvSpPr>
-          <p:cNvPr id="4" name="TextBox 3"/>
+              <a:defRPr sz="1100" b="1">
+                <a:solidFill>
+                  <a:srgbClr val="EC4899"/>
+                </a:solidFill>
+              </a:defRPr>
+            </a:pPr>
+            <a:r>
+              <a:t>MULTI-MODAL RECOMMENDER SYSTEMS • APPLIED COMPUTER VISION &amp; NLP</a:t>
+            </a:r>
+          </a:p>
+          <a:p>
+            <a:pPr>
+              <a:defRPr sz="2200" b="1">
+                <a:solidFill>
+                  <a:srgbClr val="F8FAFC"/>
+                </a:solidFill>
+              </a:defRPr>
+            </a:pPr>
+            <a:r>
+              <a:t>Production Application Studio: Live Multi-Modal Recommendation Console</a:t>
+            </a:r>
+          </a:p>
+        </p:txBody>
+      </p:sp>
+      <p:pic>
+        <p:nvPicPr>
+          <p:cNvPr id="4" name="Picture 3" descr="01_landing_recommender_studio.png"/>
+          <p:cNvPicPr>
+            <a:picLocks noChangeAspect="1"/>
+          </p:cNvPicPr>
+          <p:nvPr/>
+        </p:nvPicPr>
+        <p:blipFill>
+          <a:blip r:embed="rId2"/>
+          <a:stretch>
+            <a:fillRect/>
+          </a:stretch>
+        </p:blipFill>
+        <p:spPr>
+          <a:xfrm>
+            <a:off x="731520" y="1645920"/>
+            <a:ext cx="6583680" cy="4572000"/>
+          </a:xfrm>
+          <a:prstGeom prst="rect">
+            <a:avLst/>
+          </a:prstGeom>
+        </p:spPr>
+      </p:pic>
+      <p:sp>
+        <p:nvSpPr>
+          <p:cNvPr id="5" name="TextBox 4"/>
           <p:cNvSpPr txBox="1"/>
           <p:nvPr/>
         </p:nvSpPr>
         <p:spPr>
           <a:xfrm>
-            <a:off x="731520" y="1371600"/>
-            <a:ext cx="10698480" cy="5029200"/>
+            <a:off x="7498079" y="1645920"/>
+            <a:ext cx="4023360" cy="4572000"/>
           </a:xfrm>
           <a:prstGeom prst="rect">
             <a:avLst/>
@@ -4304,63 +6384,68 @@
           <a:lstStyle/>
           <a:p>
             <a:pPr>
-              <a:spcBef>
-                <a:spcPts val="1200"/>
-              </a:spcBef>
               <a:defRPr sz="1500" b="1">
                 <a:solidFill>
-                  <a:srgbClr val="10B981"/>
-                </a:solidFill>
-              </a:defRPr>
-            </a:pPr>
-            <a:r>
-              <a:t>★ Validation Accuracy / Score: Achieved 94.8% on independent validation test holdout partitions.</a:t>
-            </a:r>
-          </a:p>
-          <a:p>
-            <a:pPr>
-              <a:spcBef>
-                <a:spcPts val="1200"/>
-              </a:spcBef>
-              <a:defRPr sz="1500" b="1">
-                <a:solidFill>
-                  <a:srgbClr val="10B981"/>
-                </a:solidFill>
-              </a:defRPr>
-            </a:pPr>
-            <a:r>
-              <a:t>★ F1-Score / Macro Precision: Balanced metric of 0.932 across positive and negative classification targets.</a:t>
-            </a:r>
-          </a:p>
-          <a:p>
-            <a:pPr>
-              <a:spcBef>
-                <a:spcPts val="1200"/>
-              </a:spcBef>
-              <a:defRPr sz="1500" b="1">
-                <a:solidFill>
-                  <a:srgbClr val="10B981"/>
-                </a:solidFill>
-              </a:defRPr>
-            </a:pPr>
-            <a:r>
-              <a:t>★ Inference Latency Profile: Median latency of 18.4 ms per inference query on edge CPU hardware.</a:t>
-            </a:r>
-          </a:p>
-          <a:p>
-            <a:pPr>
-              <a:spcBef>
-                <a:spcPts val="1200"/>
-              </a:spcBef>
-              <a:defRPr sz="1500" b="1">
-                <a:solidFill>
-                  <a:srgbClr val="10B981"/>
-                </a:solidFill>
-              </a:defRPr>
-            </a:pPr>
-            <a:r>
-              <a:t>★ False Positive Rate (FPR): Maintained below 2.8%, satisfying stringent operational false alarm constraints.</a:t>
-            </a:r>
+                  <a:srgbClr val="6366F1"/>
+                </a:solidFill>
+              </a:defRPr>
+            </a:pPr>
+            <a:r>
+              <a:t>Operational Studio Capabilities:</a:t>
+            </a:r>
+            <a:br/>
+          </a:p>
+          <a:p>
+            <a:pPr>
+              <a:defRPr sz="1200">
+                <a:solidFill>
+                  <a:srgbClr val="F8FAFC"/>
+                </a:solidFill>
+              </a:defRPr>
+            </a:pPr>
+            <a:r>
+              <a:t>• Real-Time Attribute Sliders: Interactive tuning of skin melanin depth, vascular undertones, body silhouette, occasion, style, and budget limits.</a:t>
+            </a:r>
+            <a:br/>
+          </a:p>
+          <a:p>
+            <a:pPr>
+              <a:defRPr sz="1200">
+                <a:solidFill>
+                  <a:srgbClr val="F8FAFC"/>
+                </a:solidFill>
+              </a:defRPr>
+            </a:pPr>
+            <a:r>
+              <a:t>• 4 Benchmark Persona Presets: One-click profile switches (Fair Gala, Medium Formal, Olive Ethnic, Deep Casual).</a:t>
+            </a:r>
+            <a:br/>
+          </a:p>
+          <a:p>
+            <a:pPr>
+              <a:defRPr sz="1200">
+                <a:solidFill>
+                  <a:srgbClr val="F8FAFC"/>
+                </a:solidFill>
+              </a:defRPr>
+            </a:pPr>
+            <a:r>
+              <a:t>• Dynamic Telemetry Banner: Displays GBM predicted preferred category, prediction confidence, candidates analyzed, and sub-15ms latency.</a:t>
+            </a:r>
+            <a:br/>
+          </a:p>
+          <a:p>
+            <a:pPr>
+              <a:defRPr sz="1200">
+                <a:solidFill>
+                  <a:srgbClr val="F8FAFC"/>
+                </a:solidFill>
+              </a:defRPr>
+            </a:pPr>
+            <a:r>
+              <a:t>• Curated Outfit Cards: Displays high-res photograph, match score percentage, component bars, and style rationale.</a:t>
+            </a:r>
+            <a:br/>
           </a:p>
         </p:txBody>
       </p:sp>
@@ -4391,13 +6476,13 @@
         <p:spPr>
           <a:xfrm>
             <a:off x="0" y="0"/>
-            <a:ext cx="12191695" cy="1097280"/>
+            <a:ext cx="12191695" cy="6858000"/>
           </a:xfrm>
           <a:prstGeom prst="rect">
             <a:avLst/>
           </a:prstGeom>
           <a:solidFill>
-            <a:srgbClr val="0F172A"/>
+            <a:srgbClr val="0A0E17"/>
           </a:solidFill>
           <a:ln>
             <a:noFill/>
@@ -4433,8 +6518,8 @@
         </p:nvSpPr>
         <p:spPr>
           <a:xfrm>
-            <a:off x="731520" y="137160"/>
-            <a:ext cx="10698480" cy="822960"/>
+            <a:off x="731520" y="365760"/>
+            <a:ext cx="10728655" cy="1005840"/>
           </a:xfrm>
           <a:prstGeom prst="rect">
             <a:avLst/>
@@ -4448,40 +6533,64 @@
           <a:lstStyle/>
           <a:p>
             <a:pPr>
-              <a:defRPr sz="2400" b="1">
-                <a:solidFill>
-                  <a:srgbClr val="FFFFFF"/>
-                </a:solidFill>
-              </a:defRPr>
-            </a:pPr>
-            <a:r>
-              <a:t>6. Technology Stack &amp; Production Deployment</a:t>
-            </a:r>
-          </a:p>
-          <a:p>
-            <a:pPr>
-              <a:defRPr sz="1100">
-                <a:solidFill>
-                  <a:srgbClr val="94A3B8"/>
-                </a:solidFill>
-              </a:defRPr>
-            </a:pPr>
-            <a:r>
-              <a:t>Academic &amp; Industrial AI Project Series  |  Project 18 of 55</a:t>
-            </a:r>
-          </a:p>
-        </p:txBody>
-      </p:sp>
-      <p:sp>
-        <p:nvSpPr>
-          <p:cNvPr id="4" name="TextBox 3"/>
+              <a:defRPr sz="1100" b="1">
+                <a:solidFill>
+                  <a:srgbClr val="EC4899"/>
+                </a:solidFill>
+              </a:defRPr>
+            </a:pPr>
+            <a:r>
+              <a:t>MULTI-MODAL RECOMMENDER SYSTEMS • APPLIED COMPUTER VISION &amp; NLP</a:t>
+            </a:r>
+          </a:p>
+          <a:p>
+            <a:pPr>
+              <a:defRPr sz="2200" b="1">
+                <a:solidFill>
+                  <a:srgbClr val="F8FAFC"/>
+                </a:solidFill>
+              </a:defRPr>
+            </a:pPr>
+            <a:r>
+              <a:t>Empirical Evaluation: Fair-Cool Tone with Hourglass Silhouette (Evening Gala)</a:t>
+            </a:r>
+          </a:p>
+        </p:txBody>
+      </p:sp>
+      <p:pic>
+        <p:nvPicPr>
+          <p:cNvPr id="4" name="Picture 3" descr="02_fair_cool_gala_recommendations.png"/>
+          <p:cNvPicPr>
+            <a:picLocks noChangeAspect="1"/>
+          </p:cNvPicPr>
+          <p:nvPr/>
+        </p:nvPicPr>
+        <p:blipFill>
+          <a:blip r:embed="rId2"/>
+          <a:stretch>
+            <a:fillRect/>
+          </a:stretch>
+        </p:blipFill>
+        <p:spPr>
+          <a:xfrm>
+            <a:off x="731520" y="1645920"/>
+            <a:ext cx="6583680" cy="4572000"/>
+          </a:xfrm>
+          <a:prstGeom prst="rect">
+            <a:avLst/>
+          </a:prstGeom>
+        </p:spPr>
+      </p:pic>
+      <p:sp>
+        <p:nvSpPr>
+          <p:cNvPr id="5" name="TextBox 4"/>
           <p:cNvSpPr txBox="1"/>
           <p:nvPr/>
         </p:nvSpPr>
         <p:spPr>
           <a:xfrm>
-            <a:off x="731520" y="1371600"/>
-            <a:ext cx="10698480" cy="5029200"/>
+            <a:off x="7498079" y="1645920"/>
+            <a:ext cx="4023360" cy="4572000"/>
           </a:xfrm>
           <a:prstGeom prst="rect">
             <a:avLst/>
@@ -4495,111 +6604,81 @@
           <a:lstStyle/>
           <a:p>
             <a:pPr>
-              <a:spcBef>
-                <a:spcPts val="800"/>
-              </a:spcBef>
               <a:defRPr sz="1500" b="1">
                 <a:solidFill>
-                  <a:srgbClr val="1E3A8A"/>
-                </a:solidFill>
-              </a:defRPr>
-            </a:pPr>
-            <a:r>
-              <a:t>⚙ Core Machine Learning Framework</a:t>
-            </a:r>
-          </a:p>
-          <a:p>
-            <a:pPr>
-              <a:defRPr sz="1300">
-                <a:solidFill>
-                  <a:srgbClr val="475569"/>
-                </a:solidFill>
-              </a:defRPr>
-            </a:pPr>
-            <a:r>
-              <a:t>PyTorch 2.0+ / Scikit-learn / HuggingFace Transformers / OpenCV</a:t>
-            </a:r>
-          </a:p>
-          <a:p>
-            <a:pPr>
-              <a:spcBef>
-                <a:spcPts val="800"/>
-              </a:spcBef>
-              <a:defRPr sz="1500" b="1">
-                <a:solidFill>
-                  <a:srgbClr val="1E3A8A"/>
-                </a:solidFill>
-              </a:defRPr>
-            </a:pPr>
-            <a:r>
-              <a:t>⚙ Asynchronous REST Backend</a:t>
-            </a:r>
-          </a:p>
-          <a:p>
-            <a:pPr>
-              <a:defRPr sz="1300">
-                <a:solidFill>
-                  <a:srgbClr val="475569"/>
-                </a:solidFill>
-              </a:defRPr>
-            </a:pPr>
-            <a:r>
-              <a:t>FastAPI / Uvicorn ASGI Server / Pydantic V2 Type Safety</a:t>
-            </a:r>
-          </a:p>
-          <a:p>
-            <a:pPr>
-              <a:spcBef>
-                <a:spcPts val="800"/>
-              </a:spcBef>
-              <a:defRPr sz="1500" b="1">
-                <a:solidFill>
-                  <a:srgbClr val="1E3A8A"/>
-                </a:solidFill>
-              </a:defRPr>
-            </a:pPr>
-            <a:r>
-              <a:t>⚙ Data Persistence &amp; Storage</a:t>
-            </a:r>
-          </a:p>
-          <a:p>
-            <a:pPr>
-              <a:defRPr sz="1300">
-                <a:solidFill>
-                  <a:srgbClr val="475569"/>
-                </a:solidFill>
-              </a:defRPr>
-            </a:pPr>
-            <a:r>
-              <a:t>SQLite / PostgreSQL with transactional integrity &amp; audit trail</a:t>
-            </a:r>
-          </a:p>
-          <a:p>
-            <a:pPr>
-              <a:spcBef>
-                <a:spcPts val="800"/>
-              </a:spcBef>
-              <a:defRPr sz="1500" b="1">
-                <a:solidFill>
-                  <a:srgbClr val="1E3A8A"/>
-                </a:solidFill>
-              </a:defRPr>
-            </a:pPr>
-            <a:r>
-              <a:t>⚙ Interactive Frontend Layer</a:t>
-            </a:r>
-          </a:p>
-          <a:p>
-            <a:pPr>
-              <a:defRPr sz="1300">
-                <a:solidFill>
-                  <a:srgbClr val="475569"/>
-                </a:solidFill>
-              </a:defRPr>
-            </a:pPr>
-            <a:r>
-              <a:t>Modern Responsive Web Portal (HTML5, Tailwind/CSS, JavaScript ES6+)</a:t>
-            </a:r>
+                  <a:srgbClr val="EC4899"/>
+                </a:solidFill>
+              </a:defRPr>
+            </a:pPr>
+            <a:r>
+              <a:t>Curated Outfit Analysis:</a:t>
+            </a:r>
+            <a:br/>
+          </a:p>
+          <a:p>
+            <a:pPr>
+              <a:defRPr sz="1200">
+                <a:solidFill>
+                  <a:srgbClr val="F8FAFC"/>
+                </a:solidFill>
+              </a:defRPr>
+            </a:pPr>
+            <a:r>
+              <a:t>• Top Match: Emerald Green Wrap Maxi Dress (96% Match, ₹3,499).</a:t>
+            </a:r>
+            <a:br/>
+          </a:p>
+          <a:p>
+            <a:pPr>
+              <a:defRPr sz="1200">
+                <a:solidFill>
+                  <a:srgbClr val="F8FAFC"/>
+                </a:solidFill>
+              </a:defRPr>
+            </a:pPr>
+            <a:r>
+              <a:t>• Optical Harmony: Rich emerald green jewel tone creates high-contrast radiance against fair, cool porcelain skin.</a:t>
+            </a:r>
+            <a:br/>
+          </a:p>
+          <a:p>
+            <a:pPr>
+              <a:defRPr sz="1200">
+                <a:solidFill>
+                  <a:srgbClr val="F8FAFC"/>
+                </a:solidFill>
+              </a:defRPr>
+            </a:pPr>
+            <a:r>
+              <a:t>• Silhouette Synergy: Deep V-neckline and wrapped waist emphasize the natural waist taper of an Hourglass frame.</a:t>
+            </a:r>
+            <a:br/>
+          </a:p>
+          <a:p>
+            <a:pPr>
+              <a:defRPr sz="1200">
+                <a:solidFill>
+                  <a:srgbClr val="F8FAFC"/>
+                </a:solidFill>
+              </a:defRPr>
+            </a:pPr>
+            <a:r>
+              <a:t>• Consensus Alignment: GBM classified 'Dresses' as primary category with 82% confidence.</a:t>
+            </a:r>
+            <a:br/>
+          </a:p>
+          <a:p>
+            <a:pPr>
+              <a:defRPr sz="1200">
+                <a:solidFill>
+                  <a:srgbClr val="F8FAFC"/>
+                </a:solidFill>
+              </a:defRPr>
+            </a:pPr>
+            <a:r>
+              <a:t>• ACID Logging: Session saved to SQLite `RECOMMENDATION_HISTORY`.</a:t>
+            </a:r>
+            <a:br/>
           </a:p>
         </p:txBody>
       </p:sp>
@@ -4630,13 +6709,13 @@
         <p:spPr>
           <a:xfrm>
             <a:off x="0" y="0"/>
-            <a:ext cx="12191695" cy="1097280"/>
+            <a:ext cx="12191695" cy="6858000"/>
           </a:xfrm>
           <a:prstGeom prst="rect">
             <a:avLst/>
           </a:prstGeom>
           <a:solidFill>
-            <a:srgbClr val="0F172A"/>
+            <a:srgbClr val="0A0E17"/>
           </a:solidFill>
           <a:ln>
             <a:noFill/>
@@ -4672,8 +6751,8 @@
         </p:nvSpPr>
         <p:spPr>
           <a:xfrm>
-            <a:off x="731520" y="137160"/>
-            <a:ext cx="10698480" cy="822960"/>
+            <a:off x="731520" y="365760"/>
+            <a:ext cx="10728655" cy="1005840"/>
           </a:xfrm>
           <a:prstGeom prst="rect">
             <a:avLst/>
@@ -4687,40 +6766,64 @@
           <a:lstStyle/>
           <a:p>
             <a:pPr>
-              <a:defRPr sz="2400" b="1">
-                <a:solidFill>
-                  <a:srgbClr val="FFFFFF"/>
-                </a:solidFill>
-              </a:defRPr>
-            </a:pPr>
-            <a:r>
-              <a:t>7. Conclusion &amp; Future Roadmap</a:t>
-            </a:r>
-          </a:p>
-          <a:p>
-            <a:pPr>
-              <a:defRPr sz="1100">
-                <a:solidFill>
-                  <a:srgbClr val="94A3B8"/>
-                </a:solidFill>
-              </a:defRPr>
-            </a:pPr>
-            <a:r>
-              <a:t>Academic &amp; Industrial AI Project Series  |  Project 18 of 55</a:t>
-            </a:r>
-          </a:p>
-        </p:txBody>
-      </p:sp>
-      <p:sp>
-        <p:nvSpPr>
-          <p:cNvPr id="4" name="TextBox 3"/>
+              <a:defRPr sz="1100" b="1">
+                <a:solidFill>
+                  <a:srgbClr val="EC4899"/>
+                </a:solidFill>
+              </a:defRPr>
+            </a:pPr>
+            <a:r>
+              <a:t>MULTI-MODAL RECOMMENDER SYSTEMS • APPLIED COMPUTER VISION &amp; NLP</a:t>
+            </a:r>
+          </a:p>
+          <a:p>
+            <a:pPr>
+              <a:defRPr sz="2200" b="1">
+                <a:solidFill>
+                  <a:srgbClr val="F8FAFC"/>
+                </a:solidFill>
+              </a:defRPr>
+            </a:pPr>
+            <a:r>
+              <a:t>Empirical Evaluation: Medium-Warm Tone with Pear Silhouette (Business Formal)</a:t>
+            </a:r>
+          </a:p>
+        </p:txBody>
+      </p:sp>
+      <p:pic>
+        <p:nvPicPr>
+          <p:cNvPr id="4" name="Picture 3" descr="03_medium_warm_formal_recommendations.png"/>
+          <p:cNvPicPr>
+            <a:picLocks noChangeAspect="1"/>
+          </p:cNvPicPr>
+          <p:nvPr/>
+        </p:nvPicPr>
+        <p:blipFill>
+          <a:blip r:embed="rId2"/>
+          <a:stretch>
+            <a:fillRect/>
+          </a:stretch>
+        </p:blipFill>
+        <p:spPr>
+          <a:xfrm>
+            <a:off x="731520" y="1645920"/>
+            <a:ext cx="6583680" cy="4572000"/>
+          </a:xfrm>
+          <a:prstGeom prst="rect">
+            <a:avLst/>
+          </a:prstGeom>
+        </p:spPr>
+      </p:pic>
+      <p:sp>
+        <p:nvSpPr>
+          <p:cNvPr id="5" name="TextBox 4"/>
           <p:cNvSpPr txBox="1"/>
           <p:nvPr/>
         </p:nvSpPr>
         <p:spPr>
           <a:xfrm>
-            <a:off x="731520" y="1371600"/>
-            <a:ext cx="10698480" cy="5029200"/>
+            <a:off x="7498079" y="1645920"/>
+            <a:ext cx="4023360" cy="4572000"/>
           </a:xfrm>
           <a:prstGeom prst="rect">
             <a:avLst/>
@@ -4734,84 +6837,314 @@
           <a:lstStyle/>
           <a:p>
             <a:pPr>
-              <a:spcBef>
-                <a:spcPts val="1000"/>
-              </a:spcBef>
               <a:defRPr sz="1500" b="1">
                 <a:solidFill>
-                  <a:srgbClr val="0F172A"/>
-                </a:solidFill>
-              </a:defRPr>
-            </a:pPr>
-            <a:r>
-              <a:t>■ Project Accomplishments</a:t>
-            </a:r>
-          </a:p>
-          <a:p>
-            <a:pPr>
-              <a:defRPr sz="1300">
-                <a:solidFill>
-                  <a:srgbClr val="475569"/>
-                </a:solidFill>
-              </a:defRPr>
-            </a:pPr>
-            <a:r>
-              <a:t>Engineered a robust, end-to-end prototype validating the initial abstract with reproducible experiments.</a:t>
-            </a:r>
-          </a:p>
-          <a:p>
-            <a:pPr>
-              <a:spcBef>
-                <a:spcPts val="1000"/>
-              </a:spcBef>
+                  <a:srgbClr val="06B6D4"/>
+                </a:solidFill>
+              </a:defRPr>
+            </a:pPr>
+            <a:r>
+              <a:t>Curated Outfit Analysis:</a:t>
+            </a:r>
+            <a:br/>
+          </a:p>
+          <a:p>
+            <a:pPr>
+              <a:defRPr sz="1200">
+                <a:solidFill>
+                  <a:srgbClr val="F8FAFC"/>
+                </a:solidFill>
+              </a:defRPr>
+            </a:pPr>
+            <a:r>
+              <a:t>• Top Match: Classic Crisp White Oxford Shirt (94% Match, ₹1,899).</a:t>
+            </a:r>
+            <a:br/>
+          </a:p>
+          <a:p>
+            <a:pPr>
+              <a:defRPr sz="1200">
+                <a:solidFill>
+                  <a:srgbClr val="F8FAFC"/>
+                </a:solidFill>
+              </a:defRPr>
+            </a:pPr>
+            <a:r>
+              <a:t>• Secondary Match: Charcoal Wool Tuxedo Suit (91% Match, ₹6,499).</a:t>
+            </a:r>
+            <a:br/>
+          </a:p>
+          <a:p>
+            <a:pPr>
+              <a:defRPr sz="1200">
+                <a:solidFill>
+                  <a:srgbClr val="F8FAFC"/>
+                </a:solidFill>
+              </a:defRPr>
+            </a:pPr>
+            <a:r>
+              <a:t>• Optical Harmony: Crisp white cotton with navy/charcoal framing elevates warm golden undertones.</a:t>
+            </a:r>
+            <a:br/>
+          </a:p>
+          <a:p>
+            <a:pPr>
+              <a:defRPr sz="1200">
+                <a:solidFill>
+                  <a:srgbClr val="F8FAFC"/>
+                </a:solidFill>
+              </a:defRPr>
+            </a:pPr>
+            <a:r>
+              <a:t>• Silhouette Synergy: Structured collar and shoulder yoke balance wider hip proportions in Pear silhouettes.</a:t>
+            </a:r>
+            <a:br/>
+          </a:p>
+          <a:p>
+            <a:pPr>
+              <a:defRPr sz="1200">
+                <a:solidFill>
+                  <a:srgbClr val="F8FAFC"/>
+                </a:solidFill>
+              </a:defRPr>
+            </a:pPr>
+            <a:r>
+              <a:t>• Sub-15ms Latency: Full hybrid scoring completed in 11.2 milliseconds.</a:t>
+            </a:r>
+            <a:br/>
+          </a:p>
+        </p:txBody>
+      </p:sp>
+    </p:spTree>
+  </p:cSld>
+  <p:clrMapOvr>
+    <a:masterClrMapping/>
+  </p:clrMapOvr>
+</p:sld>
+</file>
+
+<file path=ppt/slides/slide9.xml><?xml version="1.0" encoding="utf-8"?>
+<p:sld xmlns:a="http://schemas.openxmlformats.org/drawingml/2006/main" xmlns:p="http://schemas.openxmlformats.org/presentationml/2006/main" xmlns:r="http://schemas.openxmlformats.org/officeDocument/2006/relationships">
+  <p:cSld>
+    <p:spTree>
+      <p:nvGrpSpPr>
+        <p:cNvPr id="1" name=""/>
+        <p:cNvGrpSpPr/>
+        <p:nvPr/>
+      </p:nvGrpSpPr>
+      <p:grpSpPr/>
+      <p:sp>
+        <p:nvSpPr>
+          <p:cNvPr id="2" name="Rectangle 1"/>
+          <p:cNvSpPr/>
+          <p:nvPr/>
+        </p:nvSpPr>
+        <p:spPr>
+          <a:xfrm>
+            <a:off x="0" y="0"/>
+            <a:ext cx="12191695" cy="6858000"/>
+          </a:xfrm>
+          <a:prstGeom prst="rect">
+            <a:avLst/>
+          </a:prstGeom>
+          <a:solidFill>
+            <a:srgbClr val="0A0E17"/>
+          </a:solidFill>
+          <a:ln>
+            <a:noFill/>
+          </a:ln>
+        </p:spPr>
+        <p:style>
+          <a:lnRef idx="1">
+            <a:schemeClr val="accent1"/>
+          </a:lnRef>
+          <a:fillRef idx="3">
+            <a:schemeClr val="accent1"/>
+          </a:fillRef>
+          <a:effectRef idx="2">
+            <a:schemeClr val="accent1"/>
+          </a:effectRef>
+          <a:fontRef idx="minor">
+            <a:schemeClr val="lt1"/>
+          </a:fontRef>
+        </p:style>
+        <p:txBody>
+          <a:bodyPr rtlCol="0" anchor="ctr"/>
+          <a:lstStyle/>
+          <a:p>
+            <a:pPr algn="ctr"/>
+          </a:p>
+        </p:txBody>
+      </p:sp>
+      <p:sp>
+        <p:nvSpPr>
+          <p:cNvPr id="3" name="TextBox 2"/>
+          <p:cNvSpPr txBox="1"/>
+          <p:nvPr/>
+        </p:nvSpPr>
+        <p:spPr>
+          <a:xfrm>
+            <a:off x="731520" y="365760"/>
+            <a:ext cx="10728655" cy="1005840"/>
+          </a:xfrm>
+          <a:prstGeom prst="rect">
+            <a:avLst/>
+          </a:prstGeom>
+          <a:noFill/>
+        </p:spPr>
+        <p:txBody>
+          <a:bodyPr wrap="square">
+            <a:spAutoFit/>
+          </a:bodyPr>
+          <a:lstStyle/>
+          <a:p>
+            <a:pPr>
+              <a:defRPr sz="1100" b="1">
+                <a:solidFill>
+                  <a:srgbClr val="EC4899"/>
+                </a:solidFill>
+              </a:defRPr>
+            </a:pPr>
+            <a:r>
+              <a:t>MULTI-MODAL RECOMMENDER SYSTEMS • APPLIED COMPUTER VISION &amp; NLP</a:t>
+            </a:r>
+          </a:p>
+          <a:p>
+            <a:pPr>
+              <a:defRPr sz="2200" b="1">
+                <a:solidFill>
+                  <a:srgbClr val="F8FAFC"/>
+                </a:solidFill>
+              </a:defRPr>
+            </a:pPr>
+            <a:r>
+              <a:t>Empirical Evaluation: Olive-Warm Tone with Rectangle Silhouette (Traditional Ethnic)</a:t>
+            </a:r>
+          </a:p>
+        </p:txBody>
+      </p:sp>
+      <p:pic>
+        <p:nvPicPr>
+          <p:cNvPr id="4" name="Picture 3" descr="04_olive_warm_ethnic_recommendations.png"/>
+          <p:cNvPicPr>
+            <a:picLocks noChangeAspect="1"/>
+          </p:cNvPicPr>
+          <p:nvPr/>
+        </p:nvPicPr>
+        <p:blipFill>
+          <a:blip r:embed="rId2"/>
+          <a:stretch>
+            <a:fillRect/>
+          </a:stretch>
+        </p:blipFill>
+        <p:spPr>
+          <a:xfrm>
+            <a:off x="731520" y="1645920"/>
+            <a:ext cx="6583680" cy="4572000"/>
+          </a:xfrm>
+          <a:prstGeom prst="rect">
+            <a:avLst/>
+          </a:prstGeom>
+        </p:spPr>
+      </p:pic>
+      <p:sp>
+        <p:nvSpPr>
+          <p:cNvPr id="5" name="TextBox 4"/>
+          <p:cNvSpPr txBox="1"/>
+          <p:nvPr/>
+        </p:nvSpPr>
+        <p:spPr>
+          <a:xfrm>
+            <a:off x="7498079" y="1645920"/>
+            <a:ext cx="4023360" cy="4572000"/>
+          </a:xfrm>
+          <a:prstGeom prst="rect">
+            <a:avLst/>
+          </a:prstGeom>
+          <a:noFill/>
+        </p:spPr>
+        <p:txBody>
+          <a:bodyPr wrap="square">
+            <a:spAutoFit/>
+          </a:bodyPr>
+          <a:lstStyle/>
+          <a:p>
+            <a:pPr>
               <a:defRPr sz="1500" b="1">
                 <a:solidFill>
-                  <a:srgbClr val="0F172A"/>
-                </a:solidFill>
-              </a:defRPr>
-            </a:pPr>
-            <a:r>
-              <a:t>■ Industrial Significance</a:t>
-            </a:r>
-          </a:p>
-          <a:p>
-            <a:pPr>
-              <a:defRPr sz="1300">
-                <a:solidFill>
-                  <a:srgbClr val="475569"/>
-                </a:solidFill>
-              </a:defRPr>
-            </a:pPr>
-            <a:r>
-              <a:t>Eliminates latency and manual friction while ensuring high confidence automated decision support.</a:t>
-            </a:r>
-          </a:p>
-          <a:p>
-            <a:pPr>
-              <a:spcBef>
-                <a:spcPts val="1000"/>
-              </a:spcBef>
-              <a:defRPr sz="1500" b="1">
-                <a:solidFill>
-                  <a:srgbClr val="0F172A"/>
-                </a:solidFill>
-              </a:defRPr>
-            </a:pPr>
-            <a:r>
-              <a:t>■ Future Scope &amp; Extensions</a:t>
-            </a:r>
-          </a:p>
-          <a:p>
-            <a:pPr>
-              <a:defRPr sz="1300">
-                <a:solidFill>
-                  <a:srgbClr val="475569"/>
-                </a:solidFill>
-              </a:defRPr>
-            </a:pPr>
-            <a:r>
-              <a:t>Integration with federated edge sensors, distributed multi-tenant cloud clustering, and automated active learning.</a:t>
-            </a:r>
+                  <a:srgbClr val="F59E0B"/>
+                </a:solidFill>
+              </a:defRPr>
+            </a:pPr>
+            <a:r>
+              <a:t>Curated Outfit Analysis:</a:t>
+            </a:r>
+            <a:br/>
+          </a:p>
+          <a:p>
+            <a:pPr>
+              <a:defRPr sz="1200">
+                <a:solidFill>
+                  <a:srgbClr val="F8FAFC"/>
+                </a:solidFill>
+              </a:defRPr>
+            </a:pPr>
+            <a:r>
+              <a:t>• Top Match: Crimson Kanjeevaram Silk Saree (96% Match, ₹8,999).</a:t>
+            </a:r>
+            <a:br/>
+          </a:p>
+          <a:p>
+            <a:pPr>
+              <a:defRPr sz="1200">
+                <a:solidFill>
+                  <a:srgbClr val="F8FAFC"/>
+                </a:solidFill>
+              </a:defRPr>
+            </a:pPr>
+            <a:r>
+              <a:t>• Secondary Match: Golden Embroidered Silk Kurta (93% Match, ₹3,899).</a:t>
+            </a:r>
+            <a:br/>
+          </a:p>
+          <a:p>
+            <a:pPr>
+              <a:defRPr sz="1200">
+                <a:solidFill>
+                  <a:srgbClr val="F8FAFC"/>
+                </a:solidFill>
+              </a:defRPr>
+            </a:pPr>
+            <a:r>
+              <a:t>• Optical Harmony: Deep crimson with gold zari border creates radiant warmth on olive golden complexions.</a:t>
+            </a:r>
+            <a:br/>
+          </a:p>
+          <a:p>
+            <a:pPr>
+              <a:defRPr sz="1200">
+                <a:solidFill>
+                  <a:srgbClr val="F8FAFC"/>
+                </a:solidFill>
+              </a:defRPr>
+            </a:pPr>
+            <a:r>
+              <a:t>• Silhouette Synergy: Fluid pleating and pallu drape create verticality and waist definition for athletic rectangle torsos.</a:t>
+            </a:r>
+            <a:br/>
+          </a:p>
+          <a:p>
+            <a:pPr>
+              <a:defRPr sz="1200">
+                <a:solidFill>
+                  <a:srgbClr val="F8FAFC"/>
+                </a:solidFill>
+              </a:defRPr>
+            </a:pPr>
+            <a:r>
+              <a:t>• Forensic Transparency: System renders explicit style reasons for each curation.</a:t>
+            </a:r>
+            <a:br/>
           </a:p>
         </p:txBody>
       </p:sp>

</xml_diff>